<commit_message>
Yo'l Guard — iteration 5: staff-only EXE, single-confirm flow, dispatcher red texts, dynamic diagram (41 tests green)
</commit_message>
<xml_diff>
--- a/YoLGuard_Startup_Presentation.pptx
+++ b/YoLGuard_Startup_Presentation.pptx
@@ -4266,7 +4266,7 @@
               </a:defRPr>
             </a:pPr>
             <a:r>
-              <a:t>• Deterministik qoidalar (LLM emas): green — avtomatik, yellow — tekshiruv, red — jarayon to‘xtaydi</a:t>
+              <a:t>• Deterministik qoidalar (LLM emas): green — avtomatik, yellow — tekshiruv, red — naryad chiqadi</a:t>
             </a:r>
           </a:p>
         </p:txBody>
@@ -4304,7 +4304,7 @@
               </a:defRPr>
             </a:pPr>
             <a:r>
-              <a:t>• Ikki haydovchi: kod orqali ulanish (A va B tomon), sxemani ikkalasi tasdiqlaydi</a:t>
+              <a:t>• Haydovchi sxemani tasdiqlaydi (bitta tasdiq yetadi); ikkinchi haydovchi kod bilan ixtiyoriy ulanadi</a:t>
             </a:r>
           </a:p>
         </p:txBody>
@@ -4317,7 +4317,7 @@
         </p:nvSpPr>
         <p:spPr>
           <a:xfrm>
-            <a:off x="822960" y="3794760"/>
+            <a:off x="822960" y="4114800"/>
             <a:ext cx="10515600" cy="1097280"/>
           </a:xfrm>
           <a:prstGeom prst="rect">
@@ -4342,7 +4342,7 @@
               </a:defRPr>
             </a:pPr>
             <a:r>
-              <a:t>• Tasdiqdan keyin sug‘urta paketi shakllanadi (sha256 zanjirli dalillar)</a:t>
+              <a:t>• Tasdiqdan keyin mutaxassis sug‘urta paketini yig‘adi (sha256 zanjirli dalillar)</a:t>
             </a:r>
           </a:p>
         </p:txBody>
@@ -4355,7 +4355,7 @@
         </p:nvSpPr>
         <p:spPr>
           <a:xfrm>
-            <a:off x="822960" y="4480560"/>
+            <a:off x="822960" y="4800600"/>
             <a:ext cx="10515600" cy="1097280"/>
           </a:xfrm>
           <a:prstGeom prst="rect">

</xml_diff>

<commit_message>
Positioning: any-severity ДТП, B2G for police and registration companies (no 'minor')
</commit_message>
<xml_diff>
--- a/YoLGuard_Startup_Presentation.pptx
+++ b/YoLGuard_Startup_Presentation.pptx
@@ -3216,7 +3216,7 @@
               </a:defRPr>
             </a:pPr>
             <a:r>
-              <a:t>Mayda yo‘l-transport hodisalari uchun smartfon-assistent</a:t>
+              <a:t>Yo‘l-transport hodisalari uchun smartfon-assistent (B2G: politsiya va xususiy kompaniyalar)</a:t>
             </a:r>
           </a:p>
         </p:txBody>
@@ -3229,7 +3229,7 @@
         </p:nvSpPr>
         <p:spPr>
           <a:xfrm>
-            <a:off x="822960" y="2788920"/>
+            <a:off x="822960" y="3108960"/>
             <a:ext cx="10515600" cy="1097280"/>
           </a:xfrm>
           <a:prstGeom prst="rect">
@@ -3267,7 +3267,7 @@
         </p:nvSpPr>
         <p:spPr>
           <a:xfrm>
-            <a:off x="822960" y="3474720"/>
+            <a:off x="822960" y="3794760"/>
             <a:ext cx="10515600" cy="1097280"/>
           </a:xfrm>
           <a:prstGeom prst="rect">
@@ -3684,7 +3684,7 @@
               </a:defRPr>
             </a:pPr>
             <a:r>
-              <a:t>• Mayda YTH dan keyin haydovchi stressda: nima qilishni bilmaydi</a:t>
+              <a:t>• Har qanday YTH dan keyin haydovchi stressda: nima qilishni bilmaydi</a:t>
             </a:r>
           </a:p>
         </p:txBody>

</xml_diff>

<commit_message>
Pitch v2: 9 slides per ideathon template (timings, notes, Huawei plan, RU)
</commit_message>
<xml_diff>
--- a/YoLGuard_Startup_Presentation.pptx
+++ b/YoLGuard_Startup_Presentation.pptx
@@ -6,15 +6,14 @@
   </p:sldMasterIdLst>
   <p:sldIdLst>
     <p:sldId id="256" r:id="rId7"/>
-    <p:sldId id="257" r:id="rId8"/>
-    <p:sldId id="258" r:id="rId9"/>
-    <p:sldId id="259" r:id="rId10"/>
-    <p:sldId id="260" r:id="rId11"/>
-    <p:sldId id="261" r:id="rId12"/>
-    <p:sldId id="262" r:id="rId13"/>
-    <p:sldId id="263" r:id="rId14"/>
-    <p:sldId id="264" r:id="rId15"/>
-    <p:sldId id="265" r:id="rId16"/>
+    <p:sldId id="257" r:id="rId9"/>
+    <p:sldId id="258" r:id="rId10"/>
+    <p:sldId id="259" r:id="rId11"/>
+    <p:sldId id="260" r:id="rId12"/>
+    <p:sldId id="261" r:id="rId13"/>
+    <p:sldId id="262" r:id="rId14"/>
+    <p:sldId id="263" r:id="rId15"/>
+    <p:sldId id="264" r:id="rId16"/>
   </p:sldIdLst>
   <p:sldSz cx="12188952" cy="6858000" type="screen4x3"/>
   <p:notesSz cx="6858000" cy="9144000"/>
@@ -114,6 +113,986 @@
     </a:lvl9pPr>
   </p:defaultTextStyle>
 </p:presentation>
+</file>
+
+<file path=ppt/notesMasters/notesMaster1.xml><?xml version="1.0" encoding="utf-8"?>
+<p:notesMaster xmlns:a="http://schemas.openxmlformats.org/drawingml/2006/main" xmlns:p="http://schemas.openxmlformats.org/presentationml/2006/main" xmlns:r="http://schemas.openxmlformats.org/officeDocument/2006/relationships">
+  <p:cSld>
+    <p:bg>
+      <p:bgRef idx="1001">
+        <a:schemeClr val="bg1"/>
+      </p:bgRef>
+    </p:bg>
+    <p:spTree>
+      <p:nvGrpSpPr>
+        <p:cNvPr id="1" name=""/>
+        <p:cNvGrpSpPr/>
+        <p:nvPr/>
+      </p:nvGrpSpPr>
+      <p:grpSpPr>
+        <a:xfrm>
+          <a:off x="0" y="0"/>
+          <a:ext cx="0" cy="0"/>
+          <a:chOff x="0" y="0"/>
+          <a:chExt cx="0" cy="0"/>
+        </a:xfrm>
+      </p:grpSpPr>
+      <p:sp>
+        <p:nvSpPr>
+          <p:cNvPr id="2" name="Header Placeholder 1"/>
+          <p:cNvSpPr>
+            <a:spLocks noGrp="1"/>
+          </p:cNvSpPr>
+          <p:nvPr>
+            <p:ph type="hdr" sz="quarter"/>
+          </p:nvPr>
+        </p:nvSpPr>
+        <p:spPr>
+          <a:xfrm>
+            <a:off x="0" y="0"/>
+            <a:ext cx="2971800" cy="457200"/>
+          </a:xfrm>
+          <a:prstGeom prst="rect">
+            <a:avLst/>
+          </a:prstGeom>
+        </p:spPr>
+        <p:txBody>
+          <a:bodyPr vert="horz" lIns="91440" tIns="45720" rIns="91440" bIns="45720" rtlCol="0"/>
+          <a:lstStyle>
+            <a:lvl1pPr algn="l">
+              <a:defRPr sz="1200"/>
+            </a:lvl1pPr>
+          </a:lstStyle>
+          <a:p>
+            <a:endParaRPr lang="en-US"/>
+          </a:p>
+        </p:txBody>
+      </p:sp>
+      <p:sp>
+        <p:nvSpPr>
+          <p:cNvPr id="3" name="Date Placeholder 2"/>
+          <p:cNvSpPr>
+            <a:spLocks noGrp="1"/>
+          </p:cNvSpPr>
+          <p:nvPr>
+            <p:ph type="dt" idx="1"/>
+          </p:nvPr>
+        </p:nvSpPr>
+        <p:spPr>
+          <a:xfrm>
+            <a:off x="3884613" y="0"/>
+            <a:ext cx="2971800" cy="457200"/>
+          </a:xfrm>
+          <a:prstGeom prst="rect">
+            <a:avLst/>
+          </a:prstGeom>
+        </p:spPr>
+        <p:txBody>
+          <a:bodyPr vert="horz" lIns="91440" tIns="45720" rIns="91440" bIns="45720" rtlCol="0"/>
+          <a:lstStyle>
+            <a:lvl1pPr algn="r">
+              <a:defRPr sz="1200"/>
+            </a:lvl1pPr>
+          </a:lstStyle>
+          <a:p>
+            <a:fld id="{0F89C1C7-3DCD-1040-A9CF-14679D8B5DDD}" type="datetimeFigureOut">
+              <a:rPr lang="en-US" smtClean="0"/>
+              <a:t>10/17/16</a:t>
+            </a:fld>
+            <a:endParaRPr lang="en-US"/>
+          </a:p>
+        </p:txBody>
+      </p:sp>
+      <p:sp>
+        <p:nvSpPr>
+          <p:cNvPr id="4" name="Slide Image Placeholder 3"/>
+          <p:cNvSpPr>
+            <a:spLocks noGrp="1" noRot="1" noChangeAspect="1"/>
+          </p:cNvSpPr>
+          <p:nvPr>
+            <p:ph type="sldImg" idx="2"/>
+          </p:nvPr>
+        </p:nvSpPr>
+        <p:spPr>
+          <a:xfrm>
+            <a:off x="1143000" y="685800"/>
+            <a:ext cx="4572000" cy="3429000"/>
+          </a:xfrm>
+          <a:prstGeom prst="rect">
+            <a:avLst/>
+          </a:prstGeom>
+          <a:noFill/>
+          <a:ln w="12700">
+            <a:solidFill>
+              <a:prstClr val="black"/>
+            </a:solidFill>
+          </a:ln>
+        </p:spPr>
+        <p:txBody>
+          <a:bodyPr vert="horz" lIns="91440" tIns="45720" rIns="91440" bIns="45720" rtlCol="0" anchor="ctr"/>
+          <a:lstStyle/>
+          <a:p>
+            <a:endParaRPr lang="en-US"/>
+          </a:p>
+        </p:txBody>
+      </p:sp>
+      <p:sp>
+        <p:nvSpPr>
+          <p:cNvPr id="5" name="Notes Placeholder 4"/>
+          <p:cNvSpPr>
+            <a:spLocks noGrp="1"/>
+          </p:cNvSpPr>
+          <p:nvPr>
+            <p:ph type="body" sz="quarter" idx="3"/>
+          </p:nvPr>
+        </p:nvSpPr>
+        <p:spPr>
+          <a:xfrm>
+            <a:off x="685800" y="4343400"/>
+            <a:ext cx="5486400" cy="4114800"/>
+          </a:xfrm>
+          <a:prstGeom prst="rect">
+            <a:avLst/>
+          </a:prstGeom>
+        </p:spPr>
+        <p:txBody>
+          <a:bodyPr vert="horz" lIns="91440" tIns="45720" rIns="91440" bIns="45720" rtlCol="0"/>
+          <a:lstStyle/>
+          <a:p>
+            <a:pPr lvl="0"/>
+            <a:r>
+              <a:rPr lang="en-US" smtClean="0"/>
+              <a:t>Click to edit Master text styles</a:t>
+            </a:r>
+          </a:p>
+          <a:p>
+            <a:pPr lvl="1"/>
+            <a:r>
+              <a:rPr lang="en-US" smtClean="0"/>
+              <a:t>Second level</a:t>
+            </a:r>
+          </a:p>
+          <a:p>
+            <a:pPr lvl="2"/>
+            <a:r>
+              <a:rPr lang="en-US" smtClean="0"/>
+              <a:t>Third level</a:t>
+            </a:r>
+          </a:p>
+          <a:p>
+            <a:pPr lvl="3"/>
+            <a:r>
+              <a:rPr lang="en-US" smtClean="0"/>
+              <a:t>Fourth level</a:t>
+            </a:r>
+          </a:p>
+          <a:p>
+            <a:pPr lvl="4"/>
+            <a:r>
+              <a:rPr lang="en-US" smtClean="0"/>
+              <a:t>Fifth level</a:t>
+            </a:r>
+            <a:endParaRPr lang="en-US"/>
+          </a:p>
+        </p:txBody>
+      </p:sp>
+      <p:sp>
+        <p:nvSpPr>
+          <p:cNvPr id="6" name="Footer Placeholder 5"/>
+          <p:cNvSpPr>
+            <a:spLocks noGrp="1"/>
+          </p:cNvSpPr>
+          <p:nvPr>
+            <p:ph type="ftr" sz="quarter" idx="4"/>
+          </p:nvPr>
+        </p:nvSpPr>
+        <p:spPr>
+          <a:xfrm>
+            <a:off x="0" y="8685213"/>
+            <a:ext cx="2971800" cy="457200"/>
+          </a:xfrm>
+          <a:prstGeom prst="rect">
+            <a:avLst/>
+          </a:prstGeom>
+        </p:spPr>
+        <p:txBody>
+          <a:bodyPr vert="horz" lIns="91440" tIns="45720" rIns="91440" bIns="45720" rtlCol="0" anchor="b"/>
+          <a:lstStyle>
+            <a:lvl1pPr algn="l">
+              <a:defRPr sz="1200"/>
+            </a:lvl1pPr>
+          </a:lstStyle>
+          <a:p>
+            <a:endParaRPr lang="en-US"/>
+          </a:p>
+        </p:txBody>
+      </p:sp>
+      <p:sp>
+        <p:nvSpPr>
+          <p:cNvPr id="7" name="Slide Number Placeholder 6"/>
+          <p:cNvSpPr>
+            <a:spLocks noGrp="1"/>
+          </p:cNvSpPr>
+          <p:nvPr>
+            <p:ph type="sldNum" sz="quarter" idx="5"/>
+          </p:nvPr>
+        </p:nvSpPr>
+        <p:spPr>
+          <a:xfrm>
+            <a:off x="3884613" y="8685213"/>
+            <a:ext cx="2971800" cy="457200"/>
+          </a:xfrm>
+          <a:prstGeom prst="rect">
+            <a:avLst/>
+          </a:prstGeom>
+        </p:spPr>
+        <p:txBody>
+          <a:bodyPr vert="horz" lIns="91440" tIns="45720" rIns="91440" bIns="45720" rtlCol="0" anchor="b"/>
+          <a:lstStyle>
+            <a:lvl1pPr algn="r">
+              <a:defRPr sz="1200"/>
+            </a:lvl1pPr>
+          </a:lstStyle>
+          <a:p>
+            <a:fld id="{BB5E49A5-4136-284D-997B-48E1D791AD67}" type="slidenum">
+              <a:rPr lang="en-US" smtClean="0"/>
+              <a:t>‹#›</a:t>
+            </a:fld>
+            <a:endParaRPr lang="en-US"/>
+          </a:p>
+        </p:txBody>
+      </p:sp>
+    </p:spTree>
+    <p:extLst>
+      <p:ext uri="{BB962C8B-B14F-4D97-AF65-F5344CB8AC3E}">
+        <p14:creationId xmlns:p14="http://schemas.microsoft.com/office/powerpoint/2010/main" val="2623252185"/>
+      </p:ext>
+    </p:extLst>
+  </p:cSld>
+  <p:clrMap bg1="lt1" tx1="dk1" bg2="lt2" tx2="dk2" accent1="accent1" accent2="accent2" accent3="accent3" accent4="accent4" accent5="accent5" accent6="accent6" hlink="hlink" folHlink="folHlink"/>
+  <p:notesStyle>
+    <a:lvl1pPr marL="0" algn="l" defTabSz="457200" rtl="0" eaLnBrk="1" latinLnBrk="0" hangingPunct="1">
+      <a:defRPr sz="1200" kern="1200">
+        <a:solidFill>
+          <a:schemeClr val="tx1"/>
+        </a:solidFill>
+        <a:latin typeface="+mn-lt"/>
+        <a:ea typeface="+mn-ea"/>
+        <a:cs typeface="+mn-cs"/>
+      </a:defRPr>
+    </a:lvl1pPr>
+    <a:lvl2pPr marL="457200" algn="l" defTabSz="457200" rtl="0" eaLnBrk="1" latinLnBrk="0" hangingPunct="1">
+      <a:defRPr sz="1200" kern="1200">
+        <a:solidFill>
+          <a:schemeClr val="tx1"/>
+        </a:solidFill>
+        <a:latin typeface="+mn-lt"/>
+        <a:ea typeface="+mn-ea"/>
+        <a:cs typeface="+mn-cs"/>
+      </a:defRPr>
+    </a:lvl2pPr>
+    <a:lvl3pPr marL="914400" algn="l" defTabSz="457200" rtl="0" eaLnBrk="1" latinLnBrk="0" hangingPunct="1">
+      <a:defRPr sz="1200" kern="1200">
+        <a:solidFill>
+          <a:schemeClr val="tx1"/>
+        </a:solidFill>
+        <a:latin typeface="+mn-lt"/>
+        <a:ea typeface="+mn-ea"/>
+        <a:cs typeface="+mn-cs"/>
+      </a:defRPr>
+    </a:lvl3pPr>
+    <a:lvl4pPr marL="1371600" algn="l" defTabSz="457200" rtl="0" eaLnBrk="1" latinLnBrk="0" hangingPunct="1">
+      <a:defRPr sz="1200" kern="1200">
+        <a:solidFill>
+          <a:schemeClr val="tx1"/>
+        </a:solidFill>
+        <a:latin typeface="+mn-lt"/>
+        <a:ea typeface="+mn-ea"/>
+        <a:cs typeface="+mn-cs"/>
+      </a:defRPr>
+    </a:lvl4pPr>
+    <a:lvl5pPr marL="1828800" algn="l" defTabSz="457200" rtl="0" eaLnBrk="1" latinLnBrk="0" hangingPunct="1">
+      <a:defRPr sz="1200" kern="1200">
+        <a:solidFill>
+          <a:schemeClr val="tx1"/>
+        </a:solidFill>
+        <a:latin typeface="+mn-lt"/>
+        <a:ea typeface="+mn-ea"/>
+        <a:cs typeface="+mn-cs"/>
+      </a:defRPr>
+    </a:lvl5pPr>
+    <a:lvl6pPr marL="2286000" algn="l" defTabSz="457200" rtl="0" eaLnBrk="1" latinLnBrk="0" hangingPunct="1">
+      <a:defRPr sz="1200" kern="1200">
+        <a:solidFill>
+          <a:schemeClr val="tx1"/>
+        </a:solidFill>
+        <a:latin typeface="+mn-lt"/>
+        <a:ea typeface="+mn-ea"/>
+        <a:cs typeface="+mn-cs"/>
+      </a:defRPr>
+    </a:lvl6pPr>
+    <a:lvl7pPr marL="2743200" algn="l" defTabSz="457200" rtl="0" eaLnBrk="1" latinLnBrk="0" hangingPunct="1">
+      <a:defRPr sz="1200" kern="1200">
+        <a:solidFill>
+          <a:schemeClr val="tx1"/>
+        </a:solidFill>
+        <a:latin typeface="+mn-lt"/>
+        <a:ea typeface="+mn-ea"/>
+        <a:cs typeface="+mn-cs"/>
+      </a:defRPr>
+    </a:lvl7pPr>
+    <a:lvl8pPr marL="3200400" algn="l" defTabSz="457200" rtl="0" eaLnBrk="1" latinLnBrk="0" hangingPunct="1">
+      <a:defRPr sz="1200" kern="1200">
+        <a:solidFill>
+          <a:schemeClr val="tx1"/>
+        </a:solidFill>
+        <a:latin typeface="+mn-lt"/>
+        <a:ea typeface="+mn-ea"/>
+        <a:cs typeface="+mn-cs"/>
+      </a:defRPr>
+    </a:lvl8pPr>
+    <a:lvl9pPr marL="3657600" algn="l" defTabSz="457200" rtl="0" eaLnBrk="1" latinLnBrk="0" hangingPunct="1">
+      <a:defRPr sz="1200" kern="1200">
+        <a:solidFill>
+          <a:schemeClr val="tx1"/>
+        </a:solidFill>
+        <a:latin typeface="+mn-lt"/>
+        <a:ea typeface="+mn-ea"/>
+        <a:cs typeface="+mn-cs"/>
+      </a:defRPr>
+    </a:lvl9pPr>
+  </p:notesStyle>
+</p:notesMaster>
+</file>
+
+<file path=ppt/notesSlides/notesSlide1.xml><?xml version="1.0" encoding="utf-8"?>
+<p:notes xmlns:a="http://schemas.openxmlformats.org/drawingml/2006/main" xmlns:p="http://schemas.openxmlformats.org/presentationml/2006/main" xmlns:r="http://schemas.openxmlformats.org/officeDocument/2006/relationships">
+  <p:cSld>
+    <p:spTree>
+      <p:nvGrpSpPr>
+        <p:cNvPr id="1" name=""/>
+        <p:cNvGrpSpPr/>
+        <p:nvPr/>
+      </p:nvGrpSpPr>
+      <p:grpSpPr>
+        <a:xfrm>
+          <a:off x="0" y="0"/>
+          <a:ext cx="0" cy="0"/>
+          <a:chOff x="0" y="0"/>
+          <a:chExt cx="0" cy="0"/>
+        </a:xfrm>
+      </p:grpSpPr>
+      <p:sp>
+        <p:nvSpPr>
+          <p:cNvPr id="2" name="Slide Image Placeholder 1"/>
+          <p:cNvSpPr>
+            <a:spLocks noGrp="1"/>
+          </p:cNvSpPr>
+          <p:nvPr>
+            <p:ph type="sldImg" idx="2"/>
+          </p:nvPr>
+        </p:nvSpPr>
+        <p:spPr/>
+      </p:sp>
+      <p:sp>
+        <p:nvSpPr>
+          <p:cNvPr id="3" name="Notes Placeholder 2"/>
+          <p:cNvSpPr>
+            <a:spLocks noGrp="1"/>
+          </p:cNvSpPr>
+          <p:nvPr>
+            <p:ph type="body" idx="3" sz="quarter"/>
+          </p:nvPr>
+        </p:nvSpPr>
+        <p:spPr/>
+        <p:txBody>
+          <a:bodyPr/>
+          <a:lstStyle/>
+          <a:p>
+            <a:r>
+              <a:t>0:00. Представься и команду (имена!). Один слайд — один тезис: что это и для кого. Дальше — по таймингу.</a:t>
+            </a:r>
+          </a:p>
+        </p:txBody>
+      </p:sp>
+      <p:sp>
+        <p:nvSpPr>
+          <p:cNvPr id="4" name="Slide Number Placeholder 3"/>
+          <p:cNvSpPr>
+            <a:spLocks noGrp="1"/>
+          </p:cNvSpPr>
+          <p:nvPr>
+            <p:ph type="sldNum" idx="5" sz="quarter"/>
+          </p:nvPr>
+        </p:nvSpPr>
+        <p:spPr/>
+      </p:sp>
+    </p:spTree>
+  </p:cSld>
+  <p:clrMapOvr>
+    <a:masterClrMapping/>
+  </p:clrMapOvr>
+</p:notes>
+</file>
+
+<file path=ppt/notesSlides/notesSlide2.xml><?xml version="1.0" encoding="utf-8"?>
+<p:notes xmlns:a="http://schemas.openxmlformats.org/drawingml/2006/main" xmlns:p="http://schemas.openxmlformats.org/presentationml/2006/main" xmlns:r="http://schemas.openxmlformats.org/officeDocument/2006/relationships">
+  <p:cSld>
+    <p:spTree>
+      <p:nvGrpSpPr>
+        <p:cNvPr id="1" name=""/>
+        <p:cNvGrpSpPr/>
+        <p:nvPr/>
+      </p:nvGrpSpPr>
+      <p:grpSpPr>
+        <a:xfrm>
+          <a:off x="0" y="0"/>
+          <a:ext cx="0" cy="0"/>
+          <a:chOff x="0" y="0"/>
+          <a:chExt cx="0" cy="0"/>
+        </a:xfrm>
+      </p:grpSpPr>
+      <p:sp>
+        <p:nvSpPr>
+          <p:cNvPr id="2" name="Slide Image Placeholder 1"/>
+          <p:cNvSpPr>
+            <a:spLocks noGrp="1"/>
+          </p:cNvSpPr>
+          <p:nvPr>
+            <p:ph type="sldImg" idx="2"/>
+          </p:nvPr>
+        </p:nvSpPr>
+        <p:spPr/>
+      </p:sp>
+      <p:sp>
+        <p:nvSpPr>
+          <p:cNvPr id="3" name="Notes Placeholder 2"/>
+          <p:cNvSpPr>
+            <a:spLocks noGrp="1"/>
+          </p:cNvSpPr>
+          <p:nvPr>
+            <p:ph type="body" idx="3" sz="quarter"/>
+          </p:nvPr>
+        </p:nvSpPr>
+        <p:spPr/>
+        <p:txBody>
+          <a:bodyPr/>
+          <a:lstStyle/>
+          <a:p>
+            <a:r>
+              <a:t>10 секунд: только имена и кто за что отвечает. Без биографий.</a:t>
+            </a:r>
+          </a:p>
+        </p:txBody>
+      </p:sp>
+      <p:sp>
+        <p:nvSpPr>
+          <p:cNvPr id="4" name="Slide Number Placeholder 3"/>
+          <p:cNvSpPr>
+            <a:spLocks noGrp="1"/>
+          </p:cNvSpPr>
+          <p:nvPr>
+            <p:ph type="sldNum" idx="5" sz="quarter"/>
+          </p:nvPr>
+        </p:nvSpPr>
+        <p:spPr/>
+      </p:sp>
+    </p:spTree>
+  </p:cSld>
+  <p:clrMapOvr>
+    <a:masterClrMapping/>
+  </p:clrMapOvr>
+</p:notes>
+</file>
+
+<file path=ppt/notesSlides/notesSlide3.xml><?xml version="1.0" encoding="utf-8"?>
+<p:notes xmlns:a="http://schemas.openxmlformats.org/drawingml/2006/main" xmlns:p="http://schemas.openxmlformats.org/presentationml/2006/main" xmlns:r="http://schemas.openxmlformats.org/officeDocument/2006/relationships">
+  <p:cSld>
+    <p:spTree>
+      <p:nvGrpSpPr>
+        <p:cNvPr id="1" name=""/>
+        <p:cNvGrpSpPr/>
+        <p:nvPr/>
+      </p:nvGrpSpPr>
+      <p:grpSpPr>
+        <a:xfrm>
+          <a:off x="0" y="0"/>
+          <a:ext cx="0" cy="0"/>
+          <a:chOff x="0" y="0"/>
+          <a:chExt cx="0" cy="0"/>
+        </a:xfrm>
+      </p:grpSpPr>
+      <p:sp>
+        <p:nvSpPr>
+          <p:cNvPr id="2" name="Slide Image Placeholder 1"/>
+          <p:cNvSpPr>
+            <a:spLocks noGrp="1"/>
+          </p:cNvSpPr>
+          <p:nvPr>
+            <p:ph type="sldImg" idx="2"/>
+          </p:nvPr>
+        </p:nvSpPr>
+        <p:spPr/>
+      </p:sp>
+      <p:sp>
+        <p:nvSpPr>
+          <p:cNvPr id="3" name="Notes Placeholder 2"/>
+          <p:cNvSpPr>
+            <a:spLocks noGrp="1"/>
+          </p:cNvSpPr>
+          <p:nvPr>
+            <p:ph type="body" idx="3" sz="quarter"/>
+          </p:nvPr>
+        </p:nvSpPr>
+        <p:spPr/>
+        <p:txBody>
+          <a:bodyPr/>
+          <a:lstStyle/>
+          <a:p>
+            <a:r>
+              <a:t>20 секунд: покажи карту выступления. Жюри любит структуру.</a:t>
+            </a:r>
+          </a:p>
+        </p:txBody>
+      </p:sp>
+      <p:sp>
+        <p:nvSpPr>
+          <p:cNvPr id="4" name="Slide Number Placeholder 3"/>
+          <p:cNvSpPr>
+            <a:spLocks noGrp="1"/>
+          </p:cNvSpPr>
+          <p:nvPr>
+            <p:ph type="sldNum" idx="5" sz="quarter"/>
+          </p:nvPr>
+        </p:nvSpPr>
+        <p:spPr/>
+      </p:sp>
+    </p:spTree>
+  </p:cSld>
+  <p:clrMapOvr>
+    <a:masterClrMapping/>
+  </p:clrMapOvr>
+</p:notes>
+</file>
+
+<file path=ppt/notesSlides/notesSlide4.xml><?xml version="1.0" encoding="utf-8"?>
+<p:notes xmlns:a="http://schemas.openxmlformats.org/drawingml/2006/main" xmlns:p="http://schemas.openxmlformats.org/presentationml/2006/main" xmlns:r="http://schemas.openxmlformats.org/officeDocument/2006/relationships">
+  <p:cSld>
+    <p:spTree>
+      <p:nvGrpSpPr>
+        <p:cNvPr id="1" name=""/>
+        <p:cNvGrpSpPr/>
+        <p:nvPr/>
+      </p:nvGrpSpPr>
+      <p:grpSpPr>
+        <a:xfrm>
+          <a:off x="0" y="0"/>
+          <a:ext cx="0" cy="0"/>
+          <a:chOff x="0" y="0"/>
+          <a:chExt cx="0" cy="0"/>
+        </a:xfrm>
+      </p:grpSpPr>
+      <p:sp>
+        <p:nvSpPr>
+          <p:cNvPr id="2" name="Slide Image Placeholder 1"/>
+          <p:cNvSpPr>
+            <a:spLocks noGrp="1"/>
+          </p:cNvSpPr>
+          <p:nvPr>
+            <p:ph type="sldImg" idx="2"/>
+          </p:nvPr>
+        </p:nvSpPr>
+        <p:spPr/>
+      </p:sp>
+      <p:sp>
+        <p:nvSpPr>
+          <p:cNvPr id="3" name="Notes Placeholder 2"/>
+          <p:cNvSpPr>
+            <a:spLocks noGrp="1"/>
+          </p:cNvSpPr>
+          <p:nvPr>
+            <p:ph type="body" idx="3" sz="quarter"/>
+          </p:nvPr>
+        </p:nvSpPr>
+        <p:spPr/>
+        <p:txBody>
+          <a:bodyPr/>
+          <a:lstStyle/>
+          <a:p>
+            <a:r>
+              <a:t>1 минута: говори про людей, а не технологии. Узбекистан и ТУИТ упомянуть обязательно.</a:t>
+            </a:r>
+          </a:p>
+        </p:txBody>
+      </p:sp>
+      <p:sp>
+        <p:nvSpPr>
+          <p:cNvPr id="4" name="Slide Number Placeholder 3"/>
+          <p:cNvSpPr>
+            <a:spLocks noGrp="1"/>
+          </p:cNvSpPr>
+          <p:nvPr>
+            <p:ph type="sldNum" idx="5" sz="quarter"/>
+          </p:nvPr>
+        </p:nvSpPr>
+        <p:spPr/>
+      </p:sp>
+    </p:spTree>
+  </p:cSld>
+  <p:clrMapOvr>
+    <a:masterClrMapping/>
+  </p:clrMapOvr>
+</p:notes>
+</file>
+
+<file path=ppt/notesSlides/notesSlide5.xml><?xml version="1.0" encoding="utf-8"?>
+<p:notes xmlns:a="http://schemas.openxmlformats.org/drawingml/2006/main" xmlns:p="http://schemas.openxmlformats.org/presentationml/2006/main" xmlns:r="http://schemas.openxmlformats.org/officeDocument/2006/relationships">
+  <p:cSld>
+    <p:spTree>
+      <p:nvGrpSpPr>
+        <p:cNvPr id="1" name=""/>
+        <p:cNvGrpSpPr/>
+        <p:nvPr/>
+      </p:nvGrpSpPr>
+      <p:grpSpPr>
+        <a:xfrm>
+          <a:off x="0" y="0"/>
+          <a:ext cx="0" cy="0"/>
+          <a:chOff x="0" y="0"/>
+          <a:chExt cx="0" cy="0"/>
+        </a:xfrm>
+      </p:grpSpPr>
+      <p:sp>
+        <p:nvSpPr>
+          <p:cNvPr id="2" name="Slide Image Placeholder 1"/>
+          <p:cNvSpPr>
+            <a:spLocks noGrp="1"/>
+          </p:cNvSpPr>
+          <p:nvPr>
+            <p:ph type="sldImg" idx="2"/>
+          </p:nvPr>
+        </p:nvSpPr>
+        <p:spPr/>
+      </p:sp>
+      <p:sp>
+        <p:nvSpPr>
+          <p:cNvPr id="3" name="Notes Placeholder 2"/>
+          <p:cNvSpPr>
+            <a:spLocks noGrp="1"/>
+          </p:cNvSpPr>
+          <p:nvPr>
+            <p:ph type="body" idx="3" sz="quarter"/>
+          </p:nvPr>
+        </p:nvSpPr>
+        <p:spPr/>
+        <p:txBody>
+          <a:bodyPr/>
+          <a:lstStyle/>
+          <a:p>
+            <a:r>
+              <a:t>1,5 минуты: покажи живой флоу на телефоне/экране. Подчеркни, что подтверждает человек, а не ИИ.</a:t>
+            </a:r>
+          </a:p>
+        </p:txBody>
+      </p:sp>
+      <p:sp>
+        <p:nvSpPr>
+          <p:cNvPr id="4" name="Slide Number Placeholder 3"/>
+          <p:cNvSpPr>
+            <a:spLocks noGrp="1"/>
+          </p:cNvSpPr>
+          <p:nvPr>
+            <p:ph type="sldNum" idx="5" sz="quarter"/>
+          </p:nvPr>
+        </p:nvSpPr>
+        <p:spPr/>
+      </p:sp>
+    </p:spTree>
+  </p:cSld>
+  <p:clrMapOvr>
+    <a:masterClrMapping/>
+  </p:clrMapOvr>
+</p:notes>
+</file>
+
+<file path=ppt/notesSlides/notesSlide6.xml><?xml version="1.0" encoding="utf-8"?>
+<p:notes xmlns:a="http://schemas.openxmlformats.org/drawingml/2006/main" xmlns:p="http://schemas.openxmlformats.org/presentationml/2006/main" xmlns:r="http://schemas.openxmlformats.org/officeDocument/2006/relationships">
+  <p:cSld>
+    <p:spTree>
+      <p:nvGrpSpPr>
+        <p:cNvPr id="1" name=""/>
+        <p:cNvGrpSpPr/>
+        <p:nvPr/>
+      </p:nvGrpSpPr>
+      <p:grpSpPr>
+        <a:xfrm>
+          <a:off x="0" y="0"/>
+          <a:ext cx="0" cy="0"/>
+          <a:chOff x="0" y="0"/>
+          <a:chExt cx="0" cy="0"/>
+        </a:xfrm>
+      </p:grpSpPr>
+      <p:sp>
+        <p:nvSpPr>
+          <p:cNvPr id="2" name="Slide Image Placeholder 1"/>
+          <p:cNvSpPr>
+            <a:spLocks noGrp="1"/>
+          </p:cNvSpPr>
+          <p:nvPr>
+            <p:ph type="sldImg" idx="2"/>
+          </p:nvPr>
+        </p:nvSpPr>
+        <p:spPr/>
+      </p:sp>
+      <p:sp>
+        <p:nvSpPr>
+          <p:cNvPr id="3" name="Notes Placeholder 2"/>
+          <p:cNvSpPr>
+            <a:spLocks noGrp="1"/>
+          </p:cNvSpPr>
+          <p:nvPr>
+            <p:ph type="body" idx="3" sz="quarter"/>
+          </p:nvPr>
+        </p:nvSpPr>
+        <p:spPr/>
+        <p:txBody>
+          <a:bodyPr/>
+          <a:lstStyle/>
+          <a:p>
+            <a:r>
+              <a:t>1 минута: не ври, что уже используешь. Говори: направление выбрано, интеграция расписана, интерфейс готов.</a:t>
+            </a:r>
+          </a:p>
+        </p:txBody>
+      </p:sp>
+      <p:sp>
+        <p:nvSpPr>
+          <p:cNvPr id="4" name="Slide Number Placeholder 3"/>
+          <p:cNvSpPr>
+            <a:spLocks noGrp="1"/>
+          </p:cNvSpPr>
+          <p:nvPr>
+            <p:ph type="sldNum" idx="5" sz="quarter"/>
+          </p:nvPr>
+        </p:nvSpPr>
+        <p:spPr/>
+      </p:sp>
+    </p:spTree>
+  </p:cSld>
+  <p:clrMapOvr>
+    <a:masterClrMapping/>
+  </p:clrMapOvr>
+</p:notes>
+</file>
+
+<file path=ppt/notesSlides/notesSlide7.xml><?xml version="1.0" encoding="utf-8"?>
+<p:notes xmlns:a="http://schemas.openxmlformats.org/drawingml/2006/main" xmlns:p="http://schemas.openxmlformats.org/presentationml/2006/main" xmlns:r="http://schemas.openxmlformats.org/officeDocument/2006/relationships">
+  <p:cSld>
+    <p:spTree>
+      <p:nvGrpSpPr>
+        <p:cNvPr id="1" name=""/>
+        <p:cNvGrpSpPr/>
+        <p:nvPr/>
+      </p:nvGrpSpPr>
+      <p:grpSpPr>
+        <a:xfrm>
+          <a:off x="0" y="0"/>
+          <a:ext cx="0" cy="0"/>
+          <a:chOff x="0" y="0"/>
+          <a:chExt cx="0" cy="0"/>
+        </a:xfrm>
+      </p:grpSpPr>
+      <p:sp>
+        <p:nvSpPr>
+          <p:cNvPr id="2" name="Slide Image Placeholder 1"/>
+          <p:cNvSpPr>
+            <a:spLocks noGrp="1"/>
+          </p:cNvSpPr>
+          <p:nvPr>
+            <p:ph type="sldImg" idx="2"/>
+          </p:nvPr>
+        </p:nvSpPr>
+        <p:spPr/>
+      </p:sp>
+      <p:sp>
+        <p:nvSpPr>
+          <p:cNvPr id="3" name="Notes Placeholder 2"/>
+          <p:cNvSpPr>
+            <a:spLocks noGrp="1"/>
+          </p:cNvSpPr>
+          <p:nvPr>
+            <p:ph type="body" idx="3" sz="quarter"/>
+          </p:nvPr>
+        </p:nvSpPr>
+        <p:spPr/>
+        <p:txBody>
+          <a:bodyPr/>
+          <a:lstStyle/>
+          <a:p>
+            <a:r>
+              <a:t>40 секунд: цифры только честные. Нет пользователей — говори про пилот и метрику.</a:t>
+            </a:r>
+          </a:p>
+        </p:txBody>
+      </p:sp>
+      <p:sp>
+        <p:nvSpPr>
+          <p:cNvPr id="4" name="Slide Number Placeholder 3"/>
+          <p:cNvSpPr>
+            <a:spLocks noGrp="1"/>
+          </p:cNvSpPr>
+          <p:nvPr>
+            <p:ph type="sldNum" idx="5" sz="quarter"/>
+          </p:nvPr>
+        </p:nvSpPr>
+        <p:spPr/>
+      </p:sp>
+    </p:spTree>
+  </p:cSld>
+  <p:clrMapOvr>
+    <a:masterClrMapping/>
+  </p:clrMapOvr>
+</p:notes>
+</file>
+
+<file path=ppt/notesSlides/notesSlide8.xml><?xml version="1.0" encoding="utf-8"?>
+<p:notes xmlns:a="http://schemas.openxmlformats.org/drawingml/2006/main" xmlns:p="http://schemas.openxmlformats.org/presentationml/2006/main" xmlns:r="http://schemas.openxmlformats.org/officeDocument/2006/relationships">
+  <p:cSld>
+    <p:spTree>
+      <p:nvGrpSpPr>
+        <p:cNvPr id="1" name=""/>
+        <p:cNvGrpSpPr/>
+        <p:nvPr/>
+      </p:nvGrpSpPr>
+      <p:grpSpPr>
+        <a:xfrm>
+          <a:off x="0" y="0"/>
+          <a:ext cx="0" cy="0"/>
+          <a:chOff x="0" y="0"/>
+          <a:chExt cx="0" cy="0"/>
+        </a:xfrm>
+      </p:grpSpPr>
+      <p:sp>
+        <p:nvSpPr>
+          <p:cNvPr id="2" name="Slide Image Placeholder 1"/>
+          <p:cNvSpPr>
+            <a:spLocks noGrp="1"/>
+          </p:cNvSpPr>
+          <p:nvPr>
+            <p:ph type="sldImg" idx="2"/>
+          </p:nvPr>
+        </p:nvSpPr>
+        <p:spPr/>
+      </p:sp>
+      <p:sp>
+        <p:nvSpPr>
+          <p:cNvPr id="3" name="Notes Placeholder 2"/>
+          <p:cNvSpPr>
+            <a:spLocks noGrp="1"/>
+          </p:cNvSpPr>
+          <p:nvPr>
+            <p:ph type="body" idx="3" sz="quarter"/>
+          </p:nvPr>
+        </p:nvSpPr>
+        <p:spPr/>
+        <p:txBody>
+          <a:bodyPr/>
+          <a:lstStyle/>
+          <a:p>
+            <a:r>
+              <a:t>20 секунд: что дальше и что просишь. Конкретно.</a:t>
+            </a:r>
+          </a:p>
+        </p:txBody>
+      </p:sp>
+      <p:sp>
+        <p:nvSpPr>
+          <p:cNvPr id="4" name="Slide Number Placeholder 3"/>
+          <p:cNvSpPr>
+            <a:spLocks noGrp="1"/>
+          </p:cNvSpPr>
+          <p:nvPr>
+            <p:ph type="sldNum" idx="5" sz="quarter"/>
+          </p:nvPr>
+        </p:nvSpPr>
+        <p:spPr/>
+      </p:sp>
+    </p:spTree>
+  </p:cSld>
+  <p:clrMapOvr>
+    <a:masterClrMapping/>
+  </p:clrMapOvr>
+</p:notes>
+</file>
+
+<file path=ppt/notesSlides/notesSlide9.xml><?xml version="1.0" encoding="utf-8"?>
+<p:notes xmlns:a="http://schemas.openxmlformats.org/drawingml/2006/main" xmlns:p="http://schemas.openxmlformats.org/presentationml/2006/main" xmlns:r="http://schemas.openxmlformats.org/officeDocument/2006/relationships">
+  <p:cSld>
+    <p:spTree>
+      <p:nvGrpSpPr>
+        <p:cNvPr id="1" name=""/>
+        <p:cNvGrpSpPr/>
+        <p:nvPr/>
+      </p:nvGrpSpPr>
+      <p:grpSpPr>
+        <a:xfrm>
+          <a:off x="0" y="0"/>
+          <a:ext cx="0" cy="0"/>
+          <a:chOff x="0" y="0"/>
+          <a:chExt cx="0" cy="0"/>
+        </a:xfrm>
+      </p:grpSpPr>
+      <p:sp>
+        <p:nvSpPr>
+          <p:cNvPr id="2" name="Slide Image Placeholder 1"/>
+          <p:cNvSpPr>
+            <a:spLocks noGrp="1"/>
+          </p:cNvSpPr>
+          <p:nvPr>
+            <p:ph type="sldImg" idx="2"/>
+          </p:nvPr>
+        </p:nvSpPr>
+        <p:spPr/>
+      </p:sp>
+      <p:sp>
+        <p:nvSpPr>
+          <p:cNvPr id="3" name="Notes Placeholder 2"/>
+          <p:cNvSpPr>
+            <a:spLocks noGrp="1"/>
+          </p:cNvSpPr>
+          <p:nvPr>
+            <p:ph type="body" idx="3" sz="quarter"/>
+          </p:nvPr>
+        </p:nvSpPr>
+        <p:spPr/>
+        <p:txBody>
+          <a:bodyPr/>
+          <a:lstStyle/>
+          <a:p>
+            <a:r>
+              <a:t>Уложиться в 5:00. Дальше 2 минуты вопросов: отвечай коротко и честно, «не знаем» — нормально.</a:t>
+            </a:r>
+          </a:p>
+        </p:txBody>
+      </p:sp>
+      <p:sp>
+        <p:nvSpPr>
+          <p:cNvPr id="4" name="Slide Number Placeholder 3"/>
+          <p:cNvSpPr>
+            <a:spLocks noGrp="1"/>
+          </p:cNvSpPr>
+          <p:nvPr>
+            <p:ph type="sldNum" idx="5" sz="quarter"/>
+          </p:nvPr>
+        </p:nvSpPr>
+        <p:spPr/>
+      </p:sp>
+    </p:spTree>
+  </p:cSld>
+  <p:clrMapOvr>
+    <a:masterClrMapping/>
+  </p:clrMapOvr>
+</p:notes>
 </file>
 
 <file path=ppt/slideLayouts/slideLayout1.xml><?xml version="1.0" encoding="utf-8"?>
@@ -3113,7 +4092,7 @@
         </p:nvSpPr>
         <p:spPr>
           <a:xfrm>
-            <a:off x="640080" y="502920"/>
+            <a:off x="640080" y="457200"/>
             <a:ext cx="822960" cy="64008"/>
           </a:xfrm>
           <a:prstGeom prst="rect">
@@ -3156,8 +4135,8 @@
         </p:nvSpPr>
         <p:spPr>
           <a:xfrm>
-            <a:off x="640080" y="731520"/>
-            <a:ext cx="10881360" cy="1280160"/>
+            <a:off x="10332720" y="320040"/>
+            <a:ext cx="1188720" cy="457200"/>
           </a:xfrm>
           <a:prstGeom prst="rect">
             <a:avLst/>
@@ -3171,14 +4150,14 @@
           <a:lstStyle/>
           <a:p>
             <a:pPr>
-              <a:defRPr sz="4400" b="1">
-                <a:solidFill>
-                  <a:srgbClr val="F4F1EA"/>
+              <a:defRPr sz="1600" b="1">
+                <a:solidFill>
+                  <a:srgbClr val="F5A524"/>
                 </a:solidFill>
               </a:defRPr>
             </a:pPr>
             <a:r>
-              <a:t>Yo‘lGuard AI</a:t>
+              <a:t>5:00 + 2:00</a:t>
             </a:r>
           </a:p>
         </p:txBody>
@@ -3191,7 +4170,42 @@
         </p:nvSpPr>
         <p:spPr>
           <a:xfrm>
-            <a:off x="822960" y="2103120"/>
+            <a:off x="640080" y="685800"/>
+            <a:ext cx="10881360" cy="1188720"/>
+          </a:xfrm>
+          <a:prstGeom prst="rect">
+            <a:avLst/>
+          </a:prstGeom>
+          <a:noFill/>
+        </p:spPr>
+        <p:txBody>
+          <a:bodyPr wrap="none">
+            <a:spAutoFit/>
+          </a:bodyPr>
+          <a:lstStyle/>
+          <a:p>
+            <a:pPr>
+              <a:defRPr sz="5400" b="1">
+                <a:solidFill>
+                  <a:srgbClr val="F4F1EA"/>
+                </a:solidFill>
+              </a:defRPr>
+            </a:pPr>
+            <a:r>
+              <a:t>Yo‘lGuard AI</a:t>
+            </a:r>
+          </a:p>
+        </p:txBody>
+      </p:sp>
+      <p:sp>
+        <p:nvSpPr>
+          <p:cNvPr id="5" name="TextBox 4"/>
+          <p:cNvSpPr txBox="1"/>
+          <p:nvPr/>
+        </p:nvSpPr>
+        <p:spPr>
+          <a:xfrm>
+            <a:off x="822960" y="2194560"/>
             <a:ext cx="10515600" cy="1097280"/>
           </a:xfrm>
           <a:prstGeom prst="rect">
@@ -3209,27 +4223,27 @@
               <a:spcAft>
                 <a:spcPts val="600"/>
               </a:spcAft>
-              <a:defRPr sz="2200">
+              <a:defRPr sz="2400">
                 <a:solidFill>
                   <a:srgbClr val="9B968C"/>
                 </a:solidFill>
               </a:defRPr>
             </a:pPr>
             <a:r>
-              <a:t>Yo‘l-transport hodisalari uchun smartfon-assistent (B2G: politsiya va xususiy kompaniyalar)</a:t>
-            </a:r>
-          </a:p>
-        </p:txBody>
-      </p:sp>
-      <p:sp>
-        <p:nvSpPr>
-          <p:cNvPr id="5" name="TextBox 4"/>
+              <a:t>Ассистент при ДТП любой тяжести: фото → разбор ИИ → решение сотрудника.</a:t>
+            </a:r>
+          </a:p>
+        </p:txBody>
+      </p:sp>
+      <p:sp>
+        <p:nvSpPr>
+          <p:cNvPr id="6" name="TextBox 5"/>
           <p:cNvSpPr txBox="1"/>
           <p:nvPr/>
         </p:nvSpPr>
         <p:spPr>
           <a:xfrm>
-            <a:off x="822960" y="3108960"/>
+            <a:off x="822960" y="2880360"/>
             <a:ext cx="10515600" cy="1097280"/>
           </a:xfrm>
           <a:prstGeom prst="rect">
@@ -3247,27 +4261,27 @@
               <a:spcAft>
                 <a:spcPts val="600"/>
               </a:spcAft>
-              <a:defRPr sz="2200">
+              <a:defRPr sz="2400">
                 <a:solidFill>
                   <a:srgbClr val="9B968C"/>
                 </a:solidFill>
               </a:defRPr>
             </a:pPr>
             <a:r>
-              <a:t>Suratga oldingiz — sun’iy intellekt tahlil qiladi — mutaxassis qaror beradi</a:t>
-            </a:r>
-          </a:p>
-        </p:txBody>
-      </p:sp>
-      <p:sp>
-        <p:nvSpPr>
-          <p:cNvPr id="6" name="TextBox 5"/>
+              <a:t>B2G: полиция и частные компании, регистрирующие ДТП.</a:t>
+            </a:r>
+          </a:p>
+        </p:txBody>
+      </p:sp>
+      <p:sp>
+        <p:nvSpPr>
+          <p:cNvPr id="7" name="TextBox 6"/>
           <p:cNvSpPr txBox="1"/>
           <p:nvPr/>
         </p:nvSpPr>
         <p:spPr>
           <a:xfrm>
-            <a:off x="822960" y="3794760"/>
+            <a:off x="822960" y="3566160"/>
             <a:ext cx="10515600" cy="1097280"/>
           </a:xfrm>
           <a:prstGeom prst="rect">
@@ -3285,27 +4299,27 @@
               <a:spcAft>
                 <a:spcPts val="600"/>
               </a:spcAft>
-              <a:defRPr sz="2200">
+              <a:defRPr sz="2400">
                 <a:solidFill>
                   <a:srgbClr val="9B968C"/>
                 </a:solidFill>
               </a:defRPr>
             </a:pPr>
             <a:r>
-              <a:t>MVP tayyor: Android ilova  •  backend API  •  mutaxassis paneli</a:t>
-            </a:r>
-          </a:p>
-        </p:txBody>
-      </p:sp>
-      <p:sp>
-        <p:nvSpPr>
-          <p:cNvPr id="7" name="TextBox 6"/>
+              <a:t>Команда: [имена — вписать]  •  MVP готов, демо живое</a:t>
+            </a:r>
+          </a:p>
+        </p:txBody>
+      </p:sp>
+      <p:sp>
+        <p:nvSpPr>
+          <p:cNvPr id="8" name="TextBox 7"/>
           <p:cNvSpPr txBox="1"/>
           <p:nvPr/>
         </p:nvSpPr>
         <p:spPr>
           <a:xfrm>
-            <a:off x="640080" y="6263640"/>
+            <a:off x="640080" y="6309360"/>
             <a:ext cx="10881360" cy="365760"/>
           </a:xfrm>
           <a:prstGeom prst="rect">
@@ -3327,222 +4341,7 @@
               </a:defRPr>
             </a:pPr>
             <a:r>
-              <a:t>Yo‘lGuard AI  •  MVP tayyor</a:t>
-            </a:r>
-          </a:p>
-        </p:txBody>
-      </p:sp>
-    </p:spTree>
-  </p:cSld>
-  <p:clrMapOvr>
-    <a:masterClrMapping/>
-  </p:clrMapOvr>
-</p:sld>
-</file>
-
-<file path=ppt/slides/slide10.xml><?xml version="1.0" encoding="utf-8"?>
-<p:sld xmlns:a="http://schemas.openxmlformats.org/drawingml/2006/main" xmlns:p="http://schemas.openxmlformats.org/presentationml/2006/main" xmlns:r="http://schemas.openxmlformats.org/officeDocument/2006/relationships">
-  <p:cSld>
-    <p:bg>
-      <p:bgPr>
-        <a:solidFill>
-          <a:srgbClr val="0B0B0D"/>
-        </a:solidFill>
-        <a:effectLst/>
-      </p:bgPr>
-    </p:bg>
-    <p:spTree>
-      <p:nvGrpSpPr>
-        <p:cNvPr id="1" name=""/>
-        <p:cNvGrpSpPr/>
-        <p:nvPr/>
-      </p:nvGrpSpPr>
-      <p:grpSpPr/>
-      <p:sp>
-        <p:nvSpPr>
-          <p:cNvPr id="2" name="Rectangle 1"/>
-          <p:cNvSpPr/>
-          <p:nvPr/>
-        </p:nvSpPr>
-        <p:spPr>
-          <a:xfrm>
-            <a:off x="640080" y="502920"/>
-            <a:ext cx="822960" cy="64008"/>
-          </a:xfrm>
-          <a:prstGeom prst="rect">
-            <a:avLst/>
-          </a:prstGeom>
-          <a:solidFill>
-            <a:srgbClr val="F5A524"/>
-          </a:solidFill>
-          <a:ln>
-            <a:noFill/>
-          </a:ln>
-        </p:spPr>
-        <p:style>
-          <a:lnRef idx="1">
-            <a:schemeClr val="accent1"/>
-          </a:lnRef>
-          <a:fillRef idx="3">
-            <a:schemeClr val="accent1"/>
-          </a:fillRef>
-          <a:effectRef idx="2">
-            <a:schemeClr val="accent1"/>
-          </a:effectRef>
-          <a:fontRef idx="minor">
-            <a:schemeClr val="lt1"/>
-          </a:fontRef>
-        </p:style>
-        <p:txBody>
-          <a:bodyPr rtlCol="0" anchor="ctr"/>
-          <a:lstStyle/>
-          <a:p>
-            <a:pPr algn="ctr"/>
-          </a:p>
-        </p:txBody>
-      </p:sp>
-      <p:sp>
-        <p:nvSpPr>
-          <p:cNvPr id="3" name="TextBox 2"/>
-          <p:cNvSpPr txBox="1"/>
-          <p:nvPr/>
-        </p:nvSpPr>
-        <p:spPr>
-          <a:xfrm>
-            <a:off x="640080" y="731520"/>
-            <a:ext cx="10881360" cy="1280160"/>
-          </a:xfrm>
-          <a:prstGeom prst="rect">
-            <a:avLst/>
-          </a:prstGeom>
-          <a:noFill/>
-        </p:spPr>
-        <p:txBody>
-          <a:bodyPr wrap="none">
-            <a:spAutoFit/>
-          </a:bodyPr>
-          <a:lstStyle/>
-          <a:p>
-            <a:pPr>
-              <a:defRPr sz="4400" b="1">
-                <a:solidFill>
-                  <a:srgbClr val="F4F1EA"/>
-                </a:solidFill>
-              </a:defRPr>
-            </a:pPr>
-            <a:r>
-              <a:t>Rahmat!</a:t>
-            </a:r>
-          </a:p>
-        </p:txBody>
-      </p:sp>
-      <p:sp>
-        <p:nvSpPr>
-          <p:cNvPr id="4" name="TextBox 3"/>
-          <p:cNvSpPr txBox="1"/>
-          <p:nvPr/>
-        </p:nvSpPr>
-        <p:spPr>
-          <a:xfrm>
-            <a:off x="822960" y="2103120"/>
-            <a:ext cx="10515600" cy="1097280"/>
-          </a:xfrm>
-          <a:prstGeom prst="rect">
-            <a:avLst/>
-          </a:prstGeom>
-          <a:noFill/>
-        </p:spPr>
-        <p:txBody>
-          <a:bodyPr wrap="square">
-            <a:spAutoFit/>
-          </a:bodyPr>
-          <a:lstStyle/>
-          <a:p>
-            <a:pPr>
-              <a:spcAft>
-                <a:spcPts val="600"/>
-              </a:spcAft>
-              <a:defRPr sz="2200">
-                <a:solidFill>
-                  <a:srgbClr val="9B968C"/>
-                </a:solidFill>
-              </a:defRPr>
-            </a:pPr>
-            <a:r>
-              <a:t>Yo‘lGuard AI — yo‘lda xotirjamlik uchun</a:t>
-            </a:r>
-          </a:p>
-        </p:txBody>
-      </p:sp>
-      <p:sp>
-        <p:nvSpPr>
-          <p:cNvPr id="5" name="TextBox 4"/>
-          <p:cNvSpPr txBox="1"/>
-          <p:nvPr/>
-        </p:nvSpPr>
-        <p:spPr>
-          <a:xfrm>
-            <a:off x="822960" y="2788920"/>
-            <a:ext cx="10515600" cy="1097280"/>
-          </a:xfrm>
-          <a:prstGeom prst="rect">
-            <a:avLst/>
-          </a:prstGeom>
-          <a:noFill/>
-        </p:spPr>
-        <p:txBody>
-          <a:bodyPr wrap="square">
-            <a:spAutoFit/>
-          </a:bodyPr>
-          <a:lstStyle/>
-          <a:p>
-            <a:pPr>
-              <a:spcAft>
-                <a:spcPts val="600"/>
-              </a:spcAft>
-              <a:defRPr sz="2200">
-                <a:solidFill>
-                  <a:srgbClr val="9B968C"/>
-                </a:solidFill>
-              </a:defRPr>
-            </a:pPr>
-            <a:r>
-              <a:t>Demo MVP ko‘rsatishga tayyor</a:t>
-            </a:r>
-          </a:p>
-        </p:txBody>
-      </p:sp>
-      <p:sp>
-        <p:nvSpPr>
-          <p:cNvPr id="6" name="TextBox 5"/>
-          <p:cNvSpPr txBox="1"/>
-          <p:nvPr/>
-        </p:nvSpPr>
-        <p:spPr>
-          <a:xfrm>
-            <a:off x="640080" y="6263640"/>
-            <a:ext cx="10881360" cy="365760"/>
-          </a:xfrm>
-          <a:prstGeom prst="rect">
-            <a:avLst/>
-          </a:prstGeom>
-          <a:noFill/>
-        </p:spPr>
-        <p:txBody>
-          <a:bodyPr wrap="none">
-            <a:spAutoFit/>
-          </a:bodyPr>
-          <a:lstStyle/>
-          <a:p>
-            <a:pPr>
-              <a:defRPr sz="1300">
-                <a:solidFill>
-                  <a:srgbClr val="9B968C"/>
-                </a:solidFill>
-              </a:defRPr>
-            </a:pPr>
-            <a:r>
-              <a:t>Yo‘lGuard AI  •  MVP tayyor</a:t>
+              <a:t>TUIT x Huawei ICT Ideathon 2026</a:t>
             </a:r>
           </a:p>
         </p:txBody>
@@ -3581,7 +4380,7 @@
         </p:nvSpPr>
         <p:spPr>
           <a:xfrm>
-            <a:off x="640080" y="502920"/>
+            <a:off x="640080" y="457200"/>
             <a:ext cx="822960" cy="64008"/>
           </a:xfrm>
           <a:prstGeom prst="rect">
@@ -3624,8 +4423,8 @@
         </p:nvSpPr>
         <p:spPr>
           <a:xfrm>
-            <a:off x="640080" y="731520"/>
-            <a:ext cx="10881360" cy="1280160"/>
+            <a:off x="10332720" y="320040"/>
+            <a:ext cx="1188720" cy="457200"/>
           </a:xfrm>
           <a:prstGeom prst="rect">
             <a:avLst/>
@@ -3639,14 +4438,14 @@
           <a:lstStyle/>
           <a:p>
             <a:pPr>
-              <a:defRPr sz="4000" b="1">
-                <a:solidFill>
-                  <a:srgbClr val="F4F1EA"/>
+              <a:defRPr sz="1600" b="1">
+                <a:solidFill>
+                  <a:srgbClr val="F5A524"/>
                 </a:solidFill>
               </a:defRPr>
             </a:pPr>
             <a:r>
-              <a:t>Muammo</a:t>
+              <a:t>~0:10</a:t>
             </a:r>
           </a:p>
         </p:txBody>
@@ -3659,7 +4458,42 @@
         </p:nvSpPr>
         <p:spPr>
           <a:xfrm>
-            <a:off x="822960" y="2103120"/>
+            <a:off x="640080" y="685800"/>
+            <a:ext cx="10881360" cy="1188720"/>
+          </a:xfrm>
+          <a:prstGeom prst="rect">
+            <a:avLst/>
+          </a:prstGeom>
+          <a:noFill/>
+        </p:spPr>
+        <p:txBody>
+          <a:bodyPr wrap="none">
+            <a:spAutoFit/>
+          </a:bodyPr>
+          <a:lstStyle/>
+          <a:p>
+            <a:pPr>
+              <a:defRPr sz="4000" b="1">
+                <a:solidFill>
+                  <a:srgbClr val="F4F1EA"/>
+                </a:solidFill>
+              </a:defRPr>
+            </a:pPr>
+            <a:r>
+              <a:t>Команда</a:t>
+            </a:r>
+          </a:p>
+        </p:txBody>
+      </p:sp>
+      <p:sp>
+        <p:nvSpPr>
+          <p:cNvPr id="5" name="TextBox 4"/>
+          <p:cNvSpPr txBox="1"/>
+          <p:nvPr/>
+        </p:nvSpPr>
+        <p:spPr>
+          <a:xfrm>
+            <a:off x="822960" y="2194560"/>
             <a:ext cx="10515600" cy="1097280"/>
           </a:xfrm>
           <a:prstGeom prst="rect">
@@ -3684,20 +4518,20 @@
               </a:defRPr>
             </a:pPr>
             <a:r>
-              <a:t>• Har qanday YTH dan keyin haydovchi stressda: nima qilishni bilmaydi</a:t>
-            </a:r>
-          </a:p>
-        </p:txBody>
-      </p:sp>
-      <p:sp>
-        <p:nvSpPr>
-          <p:cNvPr id="5" name="TextBox 4"/>
+              <a:t>• [Имя 1 — разработчик: backend, ИИ-интеграция]</a:t>
+            </a:r>
+          </a:p>
+        </p:txBody>
+      </p:sp>
+      <p:sp>
+        <p:nvSpPr>
+          <p:cNvPr id="6" name="TextBox 5"/>
           <p:cNvSpPr txBox="1"/>
           <p:nvPr/>
         </p:nvSpPr>
         <p:spPr>
           <a:xfrm>
-            <a:off x="822960" y="2788920"/>
+            <a:off x="822960" y="2880360"/>
             <a:ext cx="10515600" cy="1097280"/>
           </a:xfrm>
           <a:prstGeom prst="rect">
@@ -3722,20 +4556,20 @@
               </a:defRPr>
             </a:pPr>
             <a:r>
-              <a:t>• Noto‘g‘ri rasmiylashtirish — sug‘urta to‘lovining rad etilishiga olib keladi</a:t>
-            </a:r>
-          </a:p>
-        </p:txBody>
-      </p:sp>
-      <p:sp>
-        <p:nvSpPr>
-          <p:cNvPr id="6" name="TextBox 5"/>
+              <a:t>• [Имя 2 — разработчик: mobile, frontend]</a:t>
+            </a:r>
+          </a:p>
+        </p:txBody>
+      </p:sp>
+      <p:sp>
+        <p:nvSpPr>
+          <p:cNvPr id="7" name="TextBox 6"/>
           <p:cNvSpPr txBox="1"/>
           <p:nvPr/>
         </p:nvSpPr>
         <p:spPr>
           <a:xfrm>
-            <a:off x="822960" y="3474720"/>
+            <a:off x="822960" y="3566160"/>
             <a:ext cx="10515600" cy="1097280"/>
           </a:xfrm>
           <a:prstGeom prst="rect">
@@ -3760,45 +4594,7 @@
               </a:defRPr>
             </a:pPr>
             <a:r>
-              <a:t>• Polosa band bo‘lib qoladi — tirbandlik va ikkilamchi hodisalar xavfi</a:t>
-            </a:r>
-          </a:p>
-        </p:txBody>
-      </p:sp>
-      <p:sp>
-        <p:nvSpPr>
-          <p:cNvPr id="7" name="TextBox 6"/>
-          <p:cNvSpPr txBox="1"/>
-          <p:nvPr/>
-        </p:nvSpPr>
-        <p:spPr>
-          <a:xfrm>
-            <a:off x="822960" y="4160520"/>
-            <a:ext cx="10515600" cy="1097280"/>
-          </a:xfrm>
-          <a:prstGeom prst="rect">
-            <a:avLst/>
-          </a:prstGeom>
-          <a:noFill/>
-        </p:spPr>
-        <p:txBody>
-          <a:bodyPr wrap="square">
-            <a:spAutoFit/>
-          </a:bodyPr>
-          <a:lstStyle/>
-          <a:p>
-            <a:pPr>
-              <a:spcAft>
-                <a:spcPts val="600"/>
-              </a:spcAft>
-              <a:defRPr sz="2200">
-                <a:solidFill>
-                  <a:srgbClr val="F4F1EA"/>
-                </a:solidFill>
-              </a:defRPr>
-            </a:pPr>
-            <a:r>
-              <a:t>• Mavjud jarayon qog‘ozbozlik va uzoq kutishga asoslangan</a:t>
+              <a:t>• Вписать реальные имена и роли до выступления!</a:t>
             </a:r>
           </a:p>
         </p:txBody>
@@ -3811,7 +4607,7 @@
         </p:nvSpPr>
         <p:spPr>
           <a:xfrm>
-            <a:off x="640080" y="6263640"/>
+            <a:off x="640080" y="6309360"/>
             <a:ext cx="10881360" cy="365760"/>
           </a:xfrm>
           <a:prstGeom prst="rect">
@@ -3833,7 +4629,7 @@
               </a:defRPr>
             </a:pPr>
             <a:r>
-              <a:t>Yo‘lGuard AI  •  MVP tayyor</a:t>
+              <a:t>TUIT x Huawei ICT Ideathon 2026</a:t>
             </a:r>
           </a:p>
         </p:txBody>
@@ -3872,7 +4668,7 @@
         </p:nvSpPr>
         <p:spPr>
           <a:xfrm>
-            <a:off x="640080" y="502920"/>
+            <a:off x="640080" y="457200"/>
             <a:ext cx="822960" cy="64008"/>
           </a:xfrm>
           <a:prstGeom prst="rect">
@@ -3915,8 +4711,8 @@
         </p:nvSpPr>
         <p:spPr>
           <a:xfrm>
-            <a:off x="640080" y="731520"/>
-            <a:ext cx="10881360" cy="1280160"/>
+            <a:off x="10332720" y="320040"/>
+            <a:ext cx="1188720" cy="457200"/>
           </a:xfrm>
           <a:prstGeom prst="rect">
             <a:avLst/>
@@ -3930,14 +4726,14 @@
           <a:lstStyle/>
           <a:p>
             <a:pPr>
-              <a:defRPr sz="4000" b="1">
-                <a:solidFill>
-                  <a:srgbClr val="F4F1EA"/>
+              <a:defRPr sz="1600" b="1">
+                <a:solidFill>
+                  <a:srgbClr val="F5A524"/>
                 </a:solidFill>
               </a:defRPr>
             </a:pPr>
             <a:r>
-              <a:t>Yechim — 4 qadam</a:t>
+              <a:t>~0:20</a:t>
             </a:r>
           </a:p>
         </p:txBody>
@@ -3950,7 +4746,42 @@
         </p:nvSpPr>
         <p:spPr>
           <a:xfrm>
-            <a:off x="822960" y="2103120"/>
+            <a:off x="640080" y="685800"/>
+            <a:ext cx="10881360" cy="1188720"/>
+          </a:xfrm>
+          <a:prstGeom prst="rect">
+            <a:avLst/>
+          </a:prstGeom>
+          <a:noFill/>
+        </p:spPr>
+        <p:txBody>
+          <a:bodyPr wrap="none">
+            <a:spAutoFit/>
+          </a:bodyPr>
+          <a:lstStyle/>
+          <a:p>
+            <a:pPr>
+              <a:defRPr sz="4000" b="1">
+                <a:solidFill>
+                  <a:srgbClr val="F4F1EA"/>
+                </a:solidFill>
+              </a:defRPr>
+            </a:pPr>
+            <a:r>
+              <a:t>План — 5 минут</a:t>
+            </a:r>
+          </a:p>
+        </p:txBody>
+      </p:sp>
+      <p:sp>
+        <p:nvSpPr>
+          <p:cNvPr id="5" name="TextBox 4"/>
+          <p:cNvSpPr txBox="1"/>
+          <p:nvPr/>
+        </p:nvSpPr>
+        <p:spPr>
+          <a:xfrm>
+            <a:off x="822960" y="2011680"/>
             <a:ext cx="10515600" cy="1097280"/>
           </a:xfrm>
           <a:prstGeom prst="rect">
@@ -3968,27 +4799,27 @@
               <a:spcAft>
                 <a:spcPts val="600"/>
               </a:spcAft>
-              <a:defRPr sz="2200">
+              <a:defRPr sz="2100">
                 <a:solidFill>
                   <a:srgbClr val="F4F1EA"/>
                 </a:solidFill>
               </a:defRPr>
             </a:pPr>
             <a:r>
-              <a:t>• 1. Triage: 6 ta oddiy savolga javob — 30 soniya (Yevroprotokol shartlari)</a:t>
-            </a:r>
-          </a:p>
-        </p:txBody>
-      </p:sp>
-      <p:sp>
-        <p:nvSpPr>
-          <p:cNvPr id="5" name="TextBox 4"/>
+              <a:t>• 1:00 — Проблема: у кого она и почему это важно</a:t>
+            </a:r>
+          </a:p>
+        </p:txBody>
+      </p:sp>
+      <p:sp>
+        <p:nvSpPr>
+          <p:cNvPr id="6" name="TextBox 5"/>
           <p:cNvSpPr txBox="1"/>
           <p:nvPr/>
         </p:nvSpPr>
         <p:spPr>
           <a:xfrm>
-            <a:off x="822960" y="2788920"/>
+            <a:off x="822960" y="2697480"/>
             <a:ext cx="10515600" cy="1097280"/>
           </a:xfrm>
           <a:prstGeom prst="rect">
@@ -4006,27 +4837,27 @@
               <a:spcAft>
                 <a:spcPts val="600"/>
               </a:spcAft>
-              <a:defRPr sz="2200">
+              <a:defRPr sz="2100">
                 <a:solidFill>
                   <a:srgbClr val="F4F1EA"/>
                 </a:solidFill>
               </a:defRPr>
             </a:pPr>
             <a:r>
-              <a:t>• 2. Foto: 6 turdagi surat — umumiy plan, ikkala avto, raqamlar, shikast</a:t>
-            </a:r>
-          </a:p>
-        </p:txBody>
-      </p:sp>
-      <p:sp>
-        <p:nvSpPr>
-          <p:cNvPr id="6" name="TextBox 5"/>
+              <a:t>• 1:30 — Наше решение и как оно работает (демо)</a:t>
+            </a:r>
+          </a:p>
+        </p:txBody>
+      </p:sp>
+      <p:sp>
+        <p:nvSpPr>
+          <p:cNvPr id="7" name="TextBox 6"/>
           <p:cNvSpPr txBox="1"/>
           <p:nvPr/>
         </p:nvSpPr>
         <p:spPr>
           <a:xfrm>
-            <a:off x="822960" y="3474720"/>
+            <a:off x="822960" y="3383280"/>
             <a:ext cx="10515600" cy="1097280"/>
           </a:xfrm>
           <a:prstGeom prst="rect">
@@ -4044,27 +4875,27 @@
               <a:spcAft>
                 <a:spcPts val="600"/>
               </a:spcAft>
-              <a:defRPr sz="2200">
+              <a:defRPr sz="2100">
                 <a:solidFill>
                   <a:srgbClr val="F4F1EA"/>
                 </a:solidFill>
               </a:defRPr>
             </a:pPr>
             <a:r>
-              <a:t>• 3. AI tahlil: hodisa chizmasi qoralamasi + tavsif + keyingi qadamlar</a:t>
-            </a:r>
-          </a:p>
-        </p:txBody>
-      </p:sp>
-      <p:sp>
-        <p:nvSpPr>
-          <p:cNvPr id="7" name="TextBox 6"/>
+              <a:t>• 1:00 — Технологии Huawei, которые используем</a:t>
+            </a:r>
+          </a:p>
+        </p:txBody>
+      </p:sp>
+      <p:sp>
+        <p:nvSpPr>
+          <p:cNvPr id="8" name="TextBox 7"/>
           <p:cNvSpPr txBox="1"/>
           <p:nvPr/>
         </p:nvSpPr>
         <p:spPr>
           <a:xfrm>
-            <a:off x="822960" y="4160520"/>
+            <a:off x="822960" y="4069080"/>
             <a:ext cx="10515600" cy="1097280"/>
           </a:xfrm>
           <a:prstGeom prst="rect">
@@ -4082,27 +4913,65 @@
               <a:spcAft>
                 <a:spcPts val="600"/>
               </a:spcAft>
-              <a:defRPr sz="2200">
+              <a:defRPr sz="2100">
                 <a:solidFill>
                   <a:srgbClr val="F4F1EA"/>
                 </a:solidFill>
               </a:defRPr>
             </a:pPr>
             <a:r>
-              <a:t>• 4. Mutaxassis: 2 tugmadan biri bilan qaror — javob ilovaga keladi</a:t>
-            </a:r>
-          </a:p>
-        </p:txBody>
-      </p:sp>
-      <p:sp>
-        <p:nvSpPr>
-          <p:cNvPr id="8" name="TextBox 7"/>
+              <a:t>• 0:40 — Эффект, пользователи, следующие шаги</a:t>
+            </a:r>
+          </a:p>
+        </p:txBody>
+      </p:sp>
+      <p:sp>
+        <p:nvSpPr>
+          <p:cNvPr id="9" name="TextBox 8"/>
           <p:cNvSpPr txBox="1"/>
           <p:nvPr/>
         </p:nvSpPr>
         <p:spPr>
           <a:xfrm>
-            <a:off x="640080" y="6263640"/>
+            <a:off x="822960" y="4754880"/>
+            <a:ext cx="10515600" cy="1097280"/>
+          </a:xfrm>
+          <a:prstGeom prst="rect">
+            <a:avLst/>
+          </a:prstGeom>
+          <a:noFill/>
+        </p:spPr>
+        <p:txBody>
+          <a:bodyPr wrap="square">
+            <a:spAutoFit/>
+          </a:bodyPr>
+          <a:lstStyle/>
+          <a:p>
+            <a:pPr>
+              <a:spcAft>
+                <a:spcPts val="600"/>
+              </a:spcAft>
+              <a:defRPr sz="2100">
+                <a:solidFill>
+                  <a:srgbClr val="F4F1EA"/>
+                </a:solidFill>
+              </a:defRPr>
+            </a:pPr>
+            <a:r>
+              <a:t>• 0:20 — Команда и что нужно от менторов</a:t>
+            </a:r>
+          </a:p>
+        </p:txBody>
+      </p:sp>
+      <p:sp>
+        <p:nvSpPr>
+          <p:cNvPr id="10" name="TextBox 9"/>
+          <p:cNvSpPr txBox="1"/>
+          <p:nvPr/>
+        </p:nvSpPr>
+        <p:spPr>
+          <a:xfrm>
+            <a:off x="640080" y="6309360"/>
             <a:ext cx="10881360" cy="365760"/>
           </a:xfrm>
           <a:prstGeom prst="rect">
@@ -4124,7 +4993,7 @@
               </a:defRPr>
             </a:pPr>
             <a:r>
-              <a:t>Yo‘lGuard AI  •  MVP tayyor</a:t>
+              <a:t>TUIT x Huawei ICT Ideathon 2026</a:t>
             </a:r>
           </a:p>
         </p:txBody>
@@ -4163,7 +5032,7 @@
         </p:nvSpPr>
         <p:spPr>
           <a:xfrm>
-            <a:off x="640080" y="502920"/>
+            <a:off x="640080" y="457200"/>
             <a:ext cx="822960" cy="64008"/>
           </a:xfrm>
           <a:prstGeom prst="rect">
@@ -4206,8 +5075,8 @@
         </p:nvSpPr>
         <p:spPr>
           <a:xfrm>
-            <a:off x="640080" y="731520"/>
-            <a:ext cx="10881360" cy="1280160"/>
+            <a:off x="10332720" y="320040"/>
+            <a:ext cx="1188720" cy="457200"/>
           </a:xfrm>
           <a:prstGeom prst="rect">
             <a:avLst/>
@@ -4221,6 +5090,41 @@
           <a:lstStyle/>
           <a:p>
             <a:pPr>
+              <a:defRPr sz="1600" b="1">
+                <a:solidFill>
+                  <a:srgbClr val="F5A524"/>
+                </a:solidFill>
+              </a:defRPr>
+            </a:pPr>
+            <a:r>
+              <a:t>~1:00</a:t>
+            </a:r>
+          </a:p>
+        </p:txBody>
+      </p:sp>
+      <p:sp>
+        <p:nvSpPr>
+          <p:cNvPr id="4" name="TextBox 3"/>
+          <p:cNvSpPr txBox="1"/>
+          <p:nvPr/>
+        </p:nvSpPr>
+        <p:spPr>
+          <a:xfrm>
+            <a:off x="640080" y="685800"/>
+            <a:ext cx="10881360" cy="1188720"/>
+          </a:xfrm>
+          <a:prstGeom prst="rect">
+            <a:avLst/>
+          </a:prstGeom>
+          <a:noFill/>
+        </p:spPr>
+        <p:txBody>
+          <a:bodyPr wrap="none">
+            <a:spAutoFit/>
+          </a:bodyPr>
+          <a:lstStyle/>
+          <a:p>
+            <a:pPr>
               <a:defRPr sz="4000" b="1">
                 <a:solidFill>
                   <a:srgbClr val="F4F1EA"/>
@@ -4228,14 +5132,14 @@
               </a:defRPr>
             </a:pPr>
             <a:r>
-              <a:t>Qanday ishlaydi</a:t>
-            </a:r>
-          </a:p>
-        </p:txBody>
-      </p:sp>
-      <p:sp>
-        <p:nvSpPr>
-          <p:cNvPr id="4" name="TextBox 3"/>
+              <a:t>Проблема</a:t>
+            </a:r>
+          </a:p>
+        </p:txBody>
+      </p:sp>
+      <p:sp>
+        <p:nvSpPr>
+          <p:cNvPr id="5" name="TextBox 4"/>
           <p:cNvSpPr txBox="1"/>
           <p:nvPr/>
         </p:nvSpPr>
@@ -4259,27 +5163,27 @@
               <a:spcAft>
                 <a:spcPts val="600"/>
               </a:spcAft>
-              <a:defRPr sz="2200">
+              <a:defRPr sz="2100">
                 <a:solidFill>
                   <a:srgbClr val="F4F1EA"/>
                 </a:solidFill>
               </a:defRPr>
             </a:pPr>
             <a:r>
-              <a:t>• Deterministik qoidalar (LLM emas): green — avtomatik, yellow — tekshiruv, red — naryad chiqadi</a:t>
-            </a:r>
-          </a:p>
-        </p:txBody>
-      </p:sp>
-      <p:sp>
-        <p:nvSpPr>
-          <p:cNvPr id="5" name="TextBox 4"/>
+              <a:t>• Водитель после ДТП в стрессе: не знает, что делать и как оформлять</a:t>
+            </a:r>
+          </a:p>
+        </p:txBody>
+      </p:sp>
+      <p:sp>
+        <p:nvSpPr>
+          <p:cNvPr id="6" name="TextBox 5"/>
           <p:cNvSpPr txBox="1"/>
           <p:nvPr/>
         </p:nvSpPr>
         <p:spPr>
           <a:xfrm>
-            <a:off x="822960" y="3108960"/>
+            <a:off x="822960" y="2788920"/>
             <a:ext cx="10515600" cy="1097280"/>
           </a:xfrm>
           <a:prstGeom prst="rect">
@@ -4297,27 +5201,27 @@
               <a:spcAft>
                 <a:spcPts val="600"/>
               </a:spcAft>
-              <a:defRPr sz="2200">
+              <a:defRPr sz="2100">
                 <a:solidFill>
                   <a:srgbClr val="F4F1EA"/>
                 </a:solidFill>
               </a:defRPr>
             </a:pPr>
             <a:r>
-              <a:t>• Haydovchi sxemani tasdiqlaydi (bitta tasdiq yetadi); ikkinchi haydovchi kod bilan ixtiyoriy ulanadi</a:t>
-            </a:r>
-          </a:p>
-        </p:txBody>
-      </p:sp>
-      <p:sp>
-        <p:nvSpPr>
-          <p:cNvPr id="6" name="TextBox 5"/>
+              <a:t>• Ошибка в оформлении = отказ страховой; полоса занята = пробки и повторные ДТП</a:t>
+            </a:r>
+          </a:p>
+        </p:txBody>
+      </p:sp>
+      <p:sp>
+        <p:nvSpPr>
+          <p:cNvPr id="7" name="TextBox 6"/>
           <p:cNvSpPr txBox="1"/>
           <p:nvPr/>
         </p:nvSpPr>
         <p:spPr>
           <a:xfrm>
-            <a:off x="822960" y="4114800"/>
+            <a:off x="822960" y="3474720"/>
             <a:ext cx="10515600" cy="1097280"/>
           </a:xfrm>
           <a:prstGeom prst="rect">
@@ -4335,27 +5239,27 @@
               <a:spcAft>
                 <a:spcPts val="600"/>
               </a:spcAft>
-              <a:defRPr sz="2200">
+              <a:defRPr sz="2100">
                 <a:solidFill>
                   <a:srgbClr val="F4F1EA"/>
                 </a:solidFill>
               </a:defRPr>
             </a:pPr>
             <a:r>
-              <a:t>• Tasdiqdan keyin mutaxassis sug‘urta paketini yig‘adi (sha256 zanjirli dalillar)</a:t>
-            </a:r>
-          </a:p>
-        </p:txBody>
-      </p:sp>
-      <p:sp>
-        <p:nvSpPr>
-          <p:cNvPr id="7" name="TextBox 6"/>
+              <a:t>• Процесс бумажный: ожидание наряда часами даже по простому случаю</a:t>
+            </a:r>
+          </a:p>
+        </p:txBody>
+      </p:sp>
+      <p:sp>
+        <p:nvSpPr>
+          <p:cNvPr id="8" name="TextBox 7"/>
           <p:cNvSpPr txBox="1"/>
           <p:nvPr/>
         </p:nvSpPr>
         <p:spPr>
           <a:xfrm>
-            <a:off x="822960" y="4800600"/>
+            <a:off x="822960" y="4160520"/>
             <a:ext cx="10515600" cy="1097280"/>
           </a:xfrm>
           <a:prstGeom prst="rect">
@@ -4373,27 +5277,27 @@
               <a:spcAft>
                 <a:spcPts val="600"/>
               </a:spcAft>
-              <a:defRPr sz="2200">
+              <a:defRPr sz="2100">
                 <a:solidFill>
                   <a:srgbClr val="F4F1EA"/>
                 </a:solidFill>
               </a:defRPr>
             </a:pPr>
             <a:r>
-              <a:t>• Maqsad-metrika: polosa bo‘shaguncha bo‘lgan vaqt</a:t>
-            </a:r>
-          </a:p>
-        </p:txBody>
-      </p:sp>
-      <p:sp>
-        <p:nvSpPr>
-          <p:cNvPr id="8" name="TextBox 7"/>
+              <a:t>• Для Узбекистана: рост автопарка, Европротокол почти не используется</a:t>
+            </a:r>
+          </a:p>
+        </p:txBody>
+      </p:sp>
+      <p:sp>
+        <p:nvSpPr>
+          <p:cNvPr id="9" name="TextBox 8"/>
           <p:cNvSpPr txBox="1"/>
           <p:nvPr/>
         </p:nvSpPr>
         <p:spPr>
           <a:xfrm>
-            <a:off x="640080" y="6263640"/>
+            <a:off x="640080" y="6309360"/>
             <a:ext cx="10881360" cy="365760"/>
           </a:xfrm>
           <a:prstGeom prst="rect">
@@ -4415,7 +5319,7 @@
               </a:defRPr>
             </a:pPr>
             <a:r>
-              <a:t>Yo‘lGuard AI  •  MVP tayyor</a:t>
+              <a:t>Критерий: проблема и актуальность — 20 б.</a:t>
             </a:r>
           </a:p>
         </p:txBody>
@@ -4454,7 +5358,7 @@
         </p:nvSpPr>
         <p:spPr>
           <a:xfrm>
-            <a:off x="640080" y="502920"/>
+            <a:off x="640080" y="457200"/>
             <a:ext cx="822960" cy="64008"/>
           </a:xfrm>
           <a:prstGeom prst="rect">
@@ -4497,8 +5401,8 @@
         </p:nvSpPr>
         <p:spPr>
           <a:xfrm>
-            <a:off x="640080" y="731520"/>
-            <a:ext cx="10881360" cy="1280160"/>
+            <a:off x="10332720" y="320040"/>
+            <a:ext cx="1188720" cy="457200"/>
           </a:xfrm>
           <a:prstGeom prst="rect">
             <a:avLst/>
@@ -4512,21 +5416,56 @@
           <a:lstStyle/>
           <a:p>
             <a:pPr>
-              <a:defRPr sz="3800" b="1">
+              <a:defRPr sz="1600" b="1">
+                <a:solidFill>
+                  <a:srgbClr val="F5A524"/>
+                </a:solidFill>
+              </a:defRPr>
+            </a:pPr>
+            <a:r>
+              <a:t>~1:30</a:t>
+            </a:r>
+          </a:p>
+        </p:txBody>
+      </p:sp>
+      <p:sp>
+        <p:nvSpPr>
+          <p:cNvPr id="4" name="TextBox 3"/>
+          <p:cNvSpPr txBox="1"/>
+          <p:nvPr/>
+        </p:nvSpPr>
+        <p:spPr>
+          <a:xfrm>
+            <a:off x="640080" y="685800"/>
+            <a:ext cx="10881360" cy="1188720"/>
+          </a:xfrm>
+          <a:prstGeom prst="rect">
+            <a:avLst/>
+          </a:prstGeom>
+          <a:noFill/>
+        </p:spPr>
+        <p:txBody>
+          <a:bodyPr wrap="none">
+            <a:spAutoFit/>
+          </a:bodyPr>
+          <a:lstStyle/>
+          <a:p>
+            <a:pPr>
+              <a:defRPr sz="4000" b="1">
                 <a:solidFill>
                   <a:srgbClr val="F4F1EA"/>
                 </a:solidFill>
               </a:defRPr>
             </a:pPr>
             <a:r>
-              <a:t>Sun’iy intellekt — halol</a:t>
-            </a:r>
-          </a:p>
-        </p:txBody>
-      </p:sp>
-      <p:sp>
-        <p:nvSpPr>
-          <p:cNvPr id="4" name="TextBox 3"/>
+              <a:t>Решение</a:t>
+            </a:r>
+          </a:p>
+        </p:txBody>
+      </p:sp>
+      <p:sp>
+        <p:nvSpPr>
+          <p:cNvPr id="5" name="TextBox 4"/>
           <p:cNvSpPr txBox="1"/>
           <p:nvPr/>
         </p:nvSpPr>
@@ -4550,27 +5489,27 @@
               <a:spcAft>
                 <a:spcPts val="600"/>
               </a:spcAft>
-              <a:defRPr sz="2200">
+              <a:defRPr sz="2000">
                 <a:solidFill>
                   <a:srgbClr val="F4F1EA"/>
                 </a:solidFill>
               </a:defRPr>
             </a:pPr>
             <a:r>
-              <a:t>• Gemini vision: fotodagi transport, urilish joyi, shikast tavsifi, ehtimoliy ssenariy</a:t>
-            </a:r>
-          </a:p>
-        </p:txBody>
-      </p:sp>
-      <p:sp>
-        <p:nvSpPr>
-          <p:cNvPr id="5" name="TextBox 4"/>
+              <a:t>• Триаж за 30 секунд → фото/видео/голос → ИИ разбирает сам (Gemini: текст, номера, тяжесть, схема-дорога)</a:t>
+            </a:r>
+          </a:p>
+        </p:txBody>
+      </p:sp>
+      <p:sp>
+        <p:nvSpPr>
+          <p:cNvPr id="6" name="TextBox 5"/>
           <p:cNvSpPr txBox="1"/>
           <p:nvPr/>
         </p:nvSpPr>
         <p:spPr>
           <a:xfrm>
-            <a:off x="822960" y="2788920"/>
+            <a:off x="822960" y="3108960"/>
             <a:ext cx="10515600" cy="1097280"/>
           </a:xfrm>
           <a:prstGeom prst="rect">
@@ -4588,27 +5527,27 @@
               <a:spcAft>
                 <a:spcPts val="600"/>
               </a:spcAft>
-              <a:defRPr sz="2200">
+              <a:defRPr sz="2000">
                 <a:solidFill>
                   <a:srgbClr val="F4F1EA"/>
                 </a:solidFill>
               </a:defRPr>
             </a:pPr>
             <a:r>
-              <a:t>• Jabrlanganlar sonini AI o‘ylab topmaydi — faqat haydovchi kiritgan triage dan olinadi</a:t>
-            </a:r>
-          </a:p>
-        </p:txBody>
-      </p:sp>
-      <p:sp>
-        <p:nvSpPr>
-          <p:cNvPr id="6" name="TextBox 5"/>
+              <a:t>• Красный случай ждёт только сотрудника; решение письмом приходит водителю</a:t>
+            </a:r>
+          </a:p>
+        </p:txBody>
+      </p:sp>
+      <p:sp>
+        <p:nvSpPr>
+          <p:cNvPr id="7" name="TextBox 6"/>
           <p:cNvSpPr txBox="1"/>
           <p:nvPr/>
         </p:nvSpPr>
         <p:spPr>
           <a:xfrm>
-            <a:off x="822960" y="3474720"/>
+            <a:off x="822960" y="3794760"/>
             <a:ext cx="10515600" cy="1097280"/>
           </a:xfrm>
           <a:prstGeom prst="rect">
@@ -4626,27 +5565,27 @@
               <a:spcAft>
                 <a:spcPts val="600"/>
               </a:spcAft>
-              <a:defRPr sz="2200">
+              <a:defRPr sz="2000">
                 <a:solidFill>
                   <a:srgbClr val="F4F1EA"/>
                 </a:solidFill>
               </a:defRPr>
             </a:pPr>
             <a:r>
-              <a:t>• Chizma — mutaxassis uchun qoralama, yuridik fakt emas</a:t>
-            </a:r>
-          </a:p>
-        </p:txBody>
-      </p:sp>
-      <p:sp>
-        <p:nvSpPr>
-          <p:cNvPr id="7" name="TextBox 6"/>
+              <a:t>• Сотрудник — только десктоп-панель: досье, 2 кнопки, страховой пакет с sha256-цепочкой</a:t>
+            </a:r>
+          </a:p>
+        </p:txBody>
+      </p:sp>
+      <p:sp>
+        <p:nvSpPr>
+          <p:cNvPr id="8" name="TextBox 7"/>
           <p:cNvSpPr txBox="1"/>
           <p:nvPr/>
         </p:nvSpPr>
         <p:spPr>
           <a:xfrm>
-            <a:off x="822960" y="4160520"/>
+            <a:off x="822960" y="4480560"/>
             <a:ext cx="10515600" cy="1097280"/>
           </a:xfrm>
           <a:prstGeom prst="rect">
@@ -4664,27 +5603,27 @@
               <a:spcAft>
                 <a:spcPts val="600"/>
               </a:spcAft>
-              <a:defRPr sz="2200">
+              <a:defRPr sz="2000">
                 <a:solidFill>
                   <a:srgbClr val="F4F1EA"/>
                 </a:solidFill>
               </a:defRPr>
             </a:pPr>
             <a:r>
-              <a:t>• Kalit bo‘lmasa yoki API ishlamasa — halol evristik fallback (aldamaydi)</a:t>
-            </a:r>
-          </a:p>
-        </p:txBody>
-      </p:sp>
-      <p:sp>
-        <p:nvSpPr>
-          <p:cNvPr id="8" name="TextBox 7"/>
+              <a:t>• ЖИВОЕ ДЕМО: SOS → фото → разбор ИИ → вердикт (MVP: Android, API, EXE, 45 тестов)</a:t>
+            </a:r>
+          </a:p>
+        </p:txBody>
+      </p:sp>
+      <p:sp>
+        <p:nvSpPr>
+          <p:cNvPr id="9" name="TextBox 8"/>
           <p:cNvSpPr txBox="1"/>
           <p:nvPr/>
         </p:nvSpPr>
         <p:spPr>
           <a:xfrm>
-            <a:off x="640080" y="6263640"/>
+            <a:off x="640080" y="6309360"/>
             <a:ext cx="10881360" cy="365760"/>
           </a:xfrm>
           <a:prstGeom prst="rect">
@@ -4706,7 +5645,7 @@
               </a:defRPr>
             </a:pPr>
             <a:r>
-              <a:t>Yo‘lGuard AI  •  MVP tayyor</a:t>
+              <a:t>Критерий: инновационность — 20 б.</a:t>
             </a:r>
           </a:p>
         </p:txBody>
@@ -4745,7 +5684,7 @@
         </p:nvSpPr>
         <p:spPr>
           <a:xfrm>
-            <a:off x="640080" y="502920"/>
+            <a:off x="640080" y="457200"/>
             <a:ext cx="822960" cy="64008"/>
           </a:xfrm>
           <a:prstGeom prst="rect">
@@ -4788,8 +5727,8 @@
         </p:nvSpPr>
         <p:spPr>
           <a:xfrm>
-            <a:off x="640080" y="731520"/>
-            <a:ext cx="10881360" cy="1280160"/>
+            <a:off x="10332720" y="320040"/>
+            <a:ext cx="1188720" cy="457200"/>
           </a:xfrm>
           <a:prstGeom prst="rect">
             <a:avLst/>
@@ -4803,21 +5742,56 @@
           <a:lstStyle/>
           <a:p>
             <a:pPr>
-              <a:defRPr sz="3800" b="1">
+              <a:defRPr sz="1600" b="1">
+                <a:solidFill>
+                  <a:srgbClr val="F5A524"/>
+                </a:solidFill>
+              </a:defRPr>
+            </a:pPr>
+            <a:r>
+              <a:t>~1:00</a:t>
+            </a:r>
+          </a:p>
+        </p:txBody>
+      </p:sp>
+      <p:sp>
+        <p:nvSpPr>
+          <p:cNvPr id="4" name="TextBox 3"/>
+          <p:cNvSpPr txBox="1"/>
+          <p:nvPr/>
+        </p:nvSpPr>
+        <p:spPr>
+          <a:xfrm>
+            <a:off x="640080" y="685800"/>
+            <a:ext cx="10881360" cy="1188720"/>
+          </a:xfrm>
+          <a:prstGeom prst="rect">
+            <a:avLst/>
+          </a:prstGeom>
+          <a:noFill/>
+        </p:spPr>
+        <p:txBody>
+          <a:bodyPr wrap="none">
+            <a:spAutoFit/>
+          </a:bodyPr>
+          <a:lstStyle/>
+          <a:p>
+            <a:pPr>
+              <a:defRPr sz="4000" b="1">
                 <a:solidFill>
                   <a:srgbClr val="F4F1EA"/>
                 </a:solidFill>
               </a:defRPr>
             </a:pPr>
             <a:r>
-              <a:t>Texnologiyalar</a:t>
-            </a:r>
-          </a:p>
-        </p:txBody>
-      </p:sp>
-      <p:sp>
-        <p:nvSpPr>
-          <p:cNvPr id="4" name="TextBox 3"/>
+              <a:t>Технологии Huawei — план</a:t>
+            </a:r>
+          </a:p>
+        </p:txBody>
+      </p:sp>
+      <p:sp>
+        <p:nvSpPr>
+          <p:cNvPr id="5" name="TextBox 4"/>
           <p:cNvSpPr txBox="1"/>
           <p:nvPr/>
         </p:nvSpPr>
@@ -4841,21 +5815,21 @@
               <a:spcAft>
                 <a:spcPts val="600"/>
               </a:spcAft>
-              <a:defRPr sz="2200">
+              <a:defRPr sz="2000">
                 <a:solidFill>
                   <a:srgbClr val="F4F1EA"/>
                 </a:solidFill>
               </a:defRPr>
             </a:pPr>
             <a:r>
-              <a:t>• Backend: FastAPI (Python), JWT + PBKDF2, RBAC rollar</a:t>
-            </a:r>
-          </a:p>
-        </p:txBody>
-      </p:sp>
-      <p:sp>
-        <p:nvSpPr>
-          <p:cNvPr id="5" name="TextBox 4"/>
+              <a:t>• СЕЙЧАС: свой стек (FastAPI + SQLite/MongoDB) — работает офлайн от вендора</a:t>
+            </a:r>
+          </a:p>
+        </p:txBody>
+      </p:sp>
+      <p:sp>
+        <p:nvSpPr>
+          <p:cNvPr id="6" name="TextBox 5"/>
           <p:cNvSpPr txBox="1"/>
           <p:nvPr/>
         </p:nvSpPr>
@@ -4879,27 +5853,27 @@
               <a:spcAft>
                 <a:spcPts val="600"/>
               </a:spcAft>
-              <a:defRPr sz="2200">
+              <a:defRPr sz="2000">
                 <a:solidFill>
                   <a:srgbClr val="F4F1EA"/>
                 </a:solidFill>
               </a:defRPr>
             </a:pPr>
             <a:r>
-              <a:t>• SQL (users, hodisalar, ishtirokchilar, dalillar) + MongoDB (AI tarixi, audit)</a:t>
-            </a:r>
-          </a:p>
-        </p:txBody>
-      </p:sp>
-      <p:sp>
-        <p:nvSpPr>
-          <p:cNvPr id="6" name="TextBox 5"/>
+              <a:t>• ПЛАН: HMS Push Kit — пуши о вердикте вместо polling; Map Kit — карта ДТП и GPS-координаты уже собираем</a:t>
+            </a:r>
+          </a:p>
+        </p:txBody>
+      </p:sp>
+      <p:sp>
+        <p:nvSpPr>
+          <p:cNvPr id="7" name="TextBox 6"/>
           <p:cNvSpPr txBox="1"/>
           <p:nvPr/>
         </p:nvSpPr>
         <p:spPr>
           <a:xfrm>
-            <a:off x="822960" y="3474720"/>
+            <a:off x="822960" y="3794760"/>
             <a:ext cx="10515600" cy="1097280"/>
           </a:xfrm>
           <a:prstGeom prst="rect">
@@ -4917,27 +5891,27 @@
               <a:spcAft>
                 <a:spcPts val="600"/>
               </a:spcAft>
-              <a:defRPr sz="2200">
+              <a:defRPr sz="2000">
                 <a:solidFill>
                   <a:srgbClr val="F4F1EA"/>
                 </a:solidFill>
               </a:defRPr>
             </a:pPr>
             <a:r>
-              <a:t>• Fayllar: magic-bytes tekshiruv, 10 MB limit, EXIF GPS, JWT bilan himoyalangan</a:t>
-            </a:r>
-          </a:p>
-        </p:txBody>
-      </p:sp>
-      <p:sp>
-        <p:nvSpPr>
-          <p:cNvPr id="7" name="TextBox 6"/>
+              <a:t>• ПЛАН: AppGallery — дистрибуция APK; Huawei Cloud — хостинг API и MongoDB</a:t>
+            </a:r>
+          </a:p>
+        </p:txBody>
+      </p:sp>
+      <p:sp>
+        <p:nvSpPr>
+          <p:cNvPr id="8" name="TextBox 7"/>
           <p:cNvSpPr txBox="1"/>
           <p:nvPr/>
         </p:nvSpPr>
         <p:spPr>
           <a:xfrm>
-            <a:off x="822960" y="4160520"/>
+            <a:off x="822960" y="4480560"/>
             <a:ext cx="10515600" cy="1097280"/>
           </a:xfrm>
           <a:prstGeom prst="rect">
@@ -4955,27 +5929,27 @@
               <a:spcAft>
                 <a:spcPts val="600"/>
               </a:spcAft>
-              <a:defRPr sz="2200">
+              <a:defRPr sz="2000">
                 <a:solidFill>
                   <a:srgbClr val="F4F1EA"/>
                 </a:solidFill>
               </a:defRPr>
             </a:pPr>
             <a:r>
-              <a:t>• Android WebView ilova + desktop mutaxassis paneli  •  33 ta avtomatik test</a:t>
-            </a:r>
-          </a:p>
-        </p:txBody>
-      </p:sp>
-      <p:sp>
-        <p:nvSpPr>
-          <p:cNvPr id="8" name="TextBox 7"/>
+              <a:t>• Реализуемо за недели: push-интерфейс уже абстрагирован (сервис push.py + SW)</a:t>
+            </a:r>
+          </a:p>
+        </p:txBody>
+      </p:sp>
+      <p:sp>
+        <p:nvSpPr>
+          <p:cNvPr id="9" name="TextBox 8"/>
           <p:cNvSpPr txBox="1"/>
           <p:nvPr/>
         </p:nvSpPr>
         <p:spPr>
           <a:xfrm>
-            <a:off x="640080" y="6263640"/>
+            <a:off x="640080" y="6309360"/>
             <a:ext cx="10881360" cy="365760"/>
           </a:xfrm>
           <a:prstGeom prst="rect">
@@ -4997,7 +5971,7 @@
               </a:defRPr>
             </a:pPr>
             <a:r>
-              <a:t>Yo‘lGuard AI  •  MVP tayyor</a:t>
+              <a:t>Критерий: технологии Huawei и реализуемость — 20 б.</a:t>
             </a:r>
           </a:p>
         </p:txBody>
@@ -5036,7 +6010,7 @@
         </p:nvSpPr>
         <p:spPr>
           <a:xfrm>
-            <a:off x="640080" y="502920"/>
+            <a:off x="640080" y="457200"/>
             <a:ext cx="822960" cy="64008"/>
           </a:xfrm>
           <a:prstGeom prst="rect">
@@ -5079,8 +6053,8 @@
         </p:nvSpPr>
         <p:spPr>
           <a:xfrm>
-            <a:off x="640080" y="731520"/>
-            <a:ext cx="10881360" cy="1280160"/>
+            <a:off x="10332720" y="320040"/>
+            <a:ext cx="1188720" cy="457200"/>
           </a:xfrm>
           <a:prstGeom prst="rect">
             <a:avLst/>
@@ -5094,14 +6068,14 @@
           <a:lstStyle/>
           <a:p>
             <a:pPr>
-              <a:defRPr sz="3800" b="1">
-                <a:solidFill>
-                  <a:srgbClr val="F4F1EA"/>
+              <a:defRPr sz="1600" b="1">
+                <a:solidFill>
+                  <a:srgbClr val="F5A524"/>
                 </a:solidFill>
               </a:defRPr>
             </a:pPr>
             <a:r>
-              <a:t>MVP holati — nimalar tayyor</a:t>
+              <a:t>~0:40</a:t>
             </a:r>
           </a:p>
         </p:txBody>
@@ -5114,7 +6088,42 @@
         </p:nvSpPr>
         <p:spPr>
           <a:xfrm>
-            <a:off x="822960" y="2103120"/>
+            <a:off x="640080" y="685800"/>
+            <a:ext cx="10881360" cy="1188720"/>
+          </a:xfrm>
+          <a:prstGeom prst="rect">
+            <a:avLst/>
+          </a:prstGeom>
+          <a:noFill/>
+        </p:spPr>
+        <p:txBody>
+          <a:bodyPr wrap="none">
+            <a:spAutoFit/>
+          </a:bodyPr>
+          <a:lstStyle/>
+          <a:p>
+            <a:pPr>
+              <a:defRPr sz="4000" b="1">
+                <a:solidFill>
+                  <a:srgbClr val="F4F1EA"/>
+                </a:solidFill>
+              </a:defRPr>
+            </a:pPr>
+            <a:r>
+              <a:t>Эффект</a:t>
+            </a:r>
+          </a:p>
+        </p:txBody>
+      </p:sp>
+      <p:sp>
+        <p:nvSpPr>
+          <p:cNvPr id="5" name="TextBox 4"/>
+          <p:cNvSpPr txBox="1"/>
+          <p:nvPr/>
+        </p:nvSpPr>
+        <p:spPr>
+          <a:xfrm>
+            <a:off x="822960" y="2194560"/>
             <a:ext cx="10515600" cy="1097280"/>
           </a:xfrm>
           <a:prstGeom prst="rect">
@@ -5139,20 +6148,20 @@
               </a:defRPr>
             </a:pPr>
             <a:r>
-              <a:t>• Android APK: stress-holatga mos oddiy interfeys (SOS ekran, 4 qadamli usta)</a:t>
-            </a:r>
-          </a:p>
-        </p:txBody>
-      </p:sp>
-      <p:sp>
-        <p:nvSpPr>
-          <p:cNvPr id="5" name="TextBox 4"/>
+              <a:t>• Метрика: время до освобождения полосы (считаем cleared_lane_at уже сейчас)</a:t>
+            </a:r>
+          </a:p>
+        </p:txBody>
+      </p:sp>
+      <p:sp>
+        <p:nvSpPr>
+          <p:cNvPr id="6" name="TextBox 5"/>
           <p:cNvSpPr txBox="1"/>
           <p:nvPr/>
         </p:nvSpPr>
         <p:spPr>
           <a:xfrm>
-            <a:off x="822960" y="2788920"/>
+            <a:off x="822960" y="2880360"/>
             <a:ext cx="10515600" cy="1097280"/>
           </a:xfrm>
           <a:prstGeom prst="rect">
@@ -5177,20 +6186,20 @@
               </a:defRPr>
             </a:pPr>
             <a:r>
-              <a:t>• Backend API: 20+ endpoint, Postman kolleksiya bilan</a:t>
-            </a:r>
-          </a:p>
-        </p:txBody>
-      </p:sp>
-      <p:sp>
-        <p:nvSpPr>
-          <p:cNvPr id="6" name="TextBox 5"/>
+              <a:t>• Пилот: ГАИ/страховая одного района → вся страна (B2G-масштабирование)</a:t>
+            </a:r>
+          </a:p>
+        </p:txBody>
+      </p:sp>
+      <p:sp>
+        <p:nvSpPr>
+          <p:cNvPr id="7" name="TextBox 6"/>
           <p:cNvSpPr txBox="1"/>
           <p:nvPr/>
         </p:nvSpPr>
         <p:spPr>
           <a:xfrm>
-            <a:off x="822960" y="3474720"/>
+            <a:off x="822960" y="3566160"/>
             <a:ext cx="10515600" cy="1097280"/>
           </a:xfrm>
           <a:prstGeom prst="rect">
@@ -5215,45 +6224,7 @@
               </a:defRPr>
             </a:pPr>
             <a:r>
-              <a:t>• Mutaxassis paneli: statistika, filtrlar, dosye, 3 xil verdikt</a:t>
-            </a:r>
-          </a:p>
-        </p:txBody>
-      </p:sp>
-      <p:sp>
-        <p:nvSpPr>
-          <p:cNvPr id="7" name="TextBox 6"/>
-          <p:cNvSpPr txBox="1"/>
-          <p:nvPr/>
-        </p:nvSpPr>
-        <p:spPr>
-          <a:xfrm>
-            <a:off x="822960" y="4160520"/>
-            <a:ext cx="10515600" cy="1097280"/>
-          </a:xfrm>
-          <a:prstGeom prst="rect">
-            <a:avLst/>
-          </a:prstGeom>
-          <a:noFill/>
-        </p:spPr>
-        <p:txBody>
-          <a:bodyPr wrap="square">
-            <a:spAutoFit/>
-          </a:bodyPr>
-          <a:lstStyle/>
-          <a:p>
-            <a:pPr>
-              <a:spcAft>
-                <a:spcPts val="600"/>
-              </a:spcAft>
-              <a:defRPr sz="2200">
-                <a:solidFill>
-                  <a:srgbClr val="F4F1EA"/>
-                </a:solidFill>
-              </a:defRPr>
-            </a:pPr>
-            <a:r>
-              <a:t>• Hujjat: o‘rnatish va arxitektura bo‘yicha to‘liq qo‘llanma (DOCX)</a:t>
+              <a:t>• Пользователи: водители, сотрудники ДПС, страховщики</a:t>
             </a:r>
           </a:p>
         </p:txBody>
@@ -5266,7 +6237,7 @@
         </p:nvSpPr>
         <p:spPr>
           <a:xfrm>
-            <a:off x="640080" y="6263640"/>
+            <a:off x="640080" y="6309360"/>
             <a:ext cx="10881360" cy="365760"/>
           </a:xfrm>
           <a:prstGeom prst="rect">
@@ -5288,7 +6259,7 @@
               </a:defRPr>
             </a:pPr>
             <a:r>
-              <a:t>Yo‘lGuard AI  •  MVP tayyor</a:t>
+              <a:t>Критерий: эффект и масштабируемость — 15 б.</a:t>
             </a:r>
           </a:p>
         </p:txBody>
@@ -5327,7 +6298,7 @@
         </p:nvSpPr>
         <p:spPr>
           <a:xfrm>
-            <a:off x="640080" y="502920"/>
+            <a:off x="640080" y="457200"/>
             <a:ext cx="822960" cy="64008"/>
           </a:xfrm>
           <a:prstGeom prst="rect">
@@ -5370,8 +6341,8 @@
         </p:nvSpPr>
         <p:spPr>
           <a:xfrm>
-            <a:off x="640080" y="731520"/>
-            <a:ext cx="10881360" cy="1280160"/>
+            <a:off x="10332720" y="320040"/>
+            <a:ext cx="1188720" cy="457200"/>
           </a:xfrm>
           <a:prstGeom prst="rect">
             <a:avLst/>
@@ -5385,14 +6356,14 @@
           <a:lstStyle/>
           <a:p>
             <a:pPr>
-              <a:defRPr sz="4000" b="1">
-                <a:solidFill>
-                  <a:srgbClr val="F4F1EA"/>
+              <a:defRPr sz="1600" b="1">
+                <a:solidFill>
+                  <a:srgbClr val="F5A524"/>
                 </a:solidFill>
               </a:defRPr>
             </a:pPr>
             <a:r>
-              <a:t>Keyingi qadamlar</a:t>
+              <a:t>~0:20</a:t>
             </a:r>
           </a:p>
         </p:txBody>
@@ -5405,7 +6376,42 @@
         </p:nvSpPr>
         <p:spPr>
           <a:xfrm>
-            <a:off x="822960" y="2103120"/>
+            <a:off x="640080" y="685800"/>
+            <a:ext cx="10881360" cy="1188720"/>
+          </a:xfrm>
+          <a:prstGeom prst="rect">
+            <a:avLst/>
+          </a:prstGeom>
+          <a:noFill/>
+        </p:spPr>
+        <p:txBody>
+          <a:bodyPr wrap="none">
+            <a:spAutoFit/>
+          </a:bodyPr>
+          <a:lstStyle/>
+          <a:p>
+            <a:pPr>
+              <a:defRPr sz="4000" b="1">
+                <a:solidFill>
+                  <a:srgbClr val="F4F1EA"/>
+                </a:solidFill>
+              </a:defRPr>
+            </a:pPr>
+            <a:r>
+              <a:t>Дальше</a:t>
+            </a:r>
+          </a:p>
+        </p:txBody>
+      </p:sp>
+      <p:sp>
+        <p:nvSpPr>
+          <p:cNvPr id="5" name="TextBox 4"/>
+          <p:cNvSpPr txBox="1"/>
+          <p:nvPr/>
+        </p:nvSpPr>
+        <p:spPr>
+          <a:xfrm>
+            <a:off x="822960" y="2286000"/>
             <a:ext cx="10515600" cy="1097280"/>
           </a:xfrm>
           <a:prstGeom prst="rect">
@@ -5423,27 +6429,27 @@
               <a:spcAft>
                 <a:spcPts val="600"/>
               </a:spcAft>
-              <a:defRPr sz="2200">
+              <a:defRPr sz="2300">
                 <a:solidFill>
                   <a:srgbClr val="F4F1EA"/>
                 </a:solidFill>
               </a:defRPr>
             </a:pPr>
             <a:r>
-              <a:t>• Universitet qoshida pilot: real haydovchilarda sinov</a:t>
-            </a:r>
-          </a:p>
-        </p:txBody>
-      </p:sp>
-      <p:sp>
-        <p:nvSpPr>
-          <p:cNvPr id="5" name="TextBox 4"/>
+              <a:t>• Пилот с университетом/страховой, OCR номеров, оценка ущерба</a:t>
+            </a:r>
+          </a:p>
+        </p:txBody>
+      </p:sp>
+      <p:sp>
+        <p:nvSpPr>
+          <p:cNvPr id="6" name="TextBox 5"/>
           <p:cNvSpPr txBox="1"/>
           <p:nvPr/>
         </p:nvSpPr>
         <p:spPr>
           <a:xfrm>
-            <a:off x="822960" y="2788920"/>
+            <a:off x="822960" y="2971800"/>
             <a:ext cx="10515600" cy="1097280"/>
           </a:xfrm>
           <a:prstGeom prst="rect">
@@ -5461,52 +6467,14 @@
               <a:spcAft>
                 <a:spcPts val="600"/>
               </a:spcAft>
-              <a:defRPr sz="2200">
+              <a:defRPr sz="2300">
                 <a:solidFill>
                   <a:srgbClr val="F4F1EA"/>
                 </a:solidFill>
               </a:defRPr>
             </a:pPr>
             <a:r>
-              <a:t>• Sug‘urta kompaniyalari va GAI bilan integratsiya</a:t>
-            </a:r>
-          </a:p>
-        </p:txBody>
-      </p:sp>
-      <p:sp>
-        <p:nvSpPr>
-          <p:cNvPr id="6" name="TextBox 5"/>
-          <p:cNvSpPr txBox="1"/>
-          <p:nvPr/>
-        </p:nvSpPr>
-        <p:spPr>
-          <a:xfrm>
-            <a:off x="822960" y="3474720"/>
-            <a:ext cx="10515600" cy="1097280"/>
-          </a:xfrm>
-          <a:prstGeom prst="rect">
-            <a:avLst/>
-          </a:prstGeom>
-          <a:noFill/>
-        </p:spPr>
-        <p:txBody>
-          <a:bodyPr wrap="square">
-            <a:spAutoFit/>
-          </a:bodyPr>
-          <a:lstStyle/>
-          <a:p>
-            <a:pPr>
-              <a:spcAft>
-                <a:spcPts val="600"/>
-              </a:spcAft>
-              <a:defRPr sz="2200">
-                <a:solidFill>
-                  <a:srgbClr val="F4F1EA"/>
-                </a:solidFill>
-              </a:defRPr>
-            </a:pPr>
-            <a:r>
-              <a:t>• Foto sifati nazorati va takroriy ishlov (AI qayta tahlil)</a:t>
+              <a:t>• Нужно от менторов: доступ к экспертизе ГАИ/страховых + грант на пилот</a:t>
             </a:r>
           </a:p>
         </p:txBody>
@@ -5519,45 +6487,7 @@
         </p:nvSpPr>
         <p:spPr>
           <a:xfrm>
-            <a:off x="822960" y="4160520"/>
-            <a:ext cx="10515600" cy="1097280"/>
-          </a:xfrm>
-          <a:prstGeom prst="rect">
-            <a:avLst/>
-          </a:prstGeom>
-          <a:noFill/>
-        </p:spPr>
-        <p:txBody>
-          <a:bodyPr wrap="square">
-            <a:spAutoFit/>
-          </a:bodyPr>
-          <a:lstStyle/>
-          <a:p>
-            <a:pPr>
-              <a:spcAft>
-                <a:spcPts val="600"/>
-              </a:spcAft>
-              <a:defRPr sz="2200">
-                <a:solidFill>
-                  <a:srgbClr val="F4F1EA"/>
-                </a:solidFill>
-              </a:defRPr>
-            </a:pPr>
-            <a:r>
-              <a:t>• iOS / PWA versiya</a:t>
-            </a:r>
-          </a:p>
-        </p:txBody>
-      </p:sp>
-      <p:sp>
-        <p:nvSpPr>
-          <p:cNvPr id="8" name="TextBox 7"/>
-          <p:cNvSpPr txBox="1"/>
-          <p:nvPr/>
-        </p:nvSpPr>
-        <p:spPr>
-          <a:xfrm>
-            <a:off x="640080" y="6263640"/>
+            <a:off x="640080" y="6309360"/>
             <a:ext cx="10881360" cy="365760"/>
           </a:xfrm>
           <a:prstGeom prst="rect">
@@ -5579,7 +6509,7 @@
               </a:defRPr>
             </a:pPr>
             <a:r>
-              <a:t>Yo‘lGuard AI  •  MVP tayyor</a:t>
+              <a:t>TUIT x Huawei ICT Ideathon 2026</a:t>
             </a:r>
           </a:p>
         </p:txBody>
@@ -5618,7 +6548,7 @@
         </p:nvSpPr>
         <p:spPr>
           <a:xfrm>
-            <a:off x="640080" y="502920"/>
+            <a:off x="640080" y="457200"/>
             <a:ext cx="822960" cy="64008"/>
           </a:xfrm>
           <a:prstGeom prst="rect">
@@ -5661,8 +6591,8 @@
         </p:nvSpPr>
         <p:spPr>
           <a:xfrm>
-            <a:off x="640080" y="731520"/>
-            <a:ext cx="10881360" cy="1280160"/>
+            <a:off x="10332720" y="320040"/>
+            <a:ext cx="1188720" cy="457200"/>
           </a:xfrm>
           <a:prstGeom prst="rect">
             <a:avLst/>
@@ -5676,14 +6606,14 @@
           <a:lstStyle/>
           <a:p>
             <a:pPr>
-              <a:defRPr sz="4000" b="1">
-                <a:solidFill>
-                  <a:srgbClr val="F4F1EA"/>
+              <a:defRPr sz="1600" b="1">
+                <a:solidFill>
+                  <a:srgbClr val="F5A524"/>
                 </a:solidFill>
               </a:defRPr>
             </a:pPr>
             <a:r>
-              <a:t>Bizga nima kerak</a:t>
+              <a:t>Вопросы — 2:00</a:t>
             </a:r>
           </a:p>
         </p:txBody>
@@ -5696,7 +6626,42 @@
         </p:nvSpPr>
         <p:spPr>
           <a:xfrm>
-            <a:off x="822960" y="2103120"/>
+            <a:off x="640080" y="685800"/>
+            <a:ext cx="10881360" cy="1188720"/>
+          </a:xfrm>
+          <a:prstGeom prst="rect">
+            <a:avLst/>
+          </a:prstGeom>
+          <a:noFill/>
+        </p:spPr>
+        <p:txBody>
+          <a:bodyPr wrap="none">
+            <a:spAutoFit/>
+          </a:bodyPr>
+          <a:lstStyle/>
+          <a:p>
+            <a:pPr>
+              <a:defRPr sz="5400" b="1">
+                <a:solidFill>
+                  <a:srgbClr val="F4F1EA"/>
+                </a:solidFill>
+              </a:defRPr>
+            </a:pPr>
+            <a:r>
+              <a:t>Спасибо!</a:t>
+            </a:r>
+          </a:p>
+        </p:txBody>
+      </p:sp>
+      <p:sp>
+        <p:nvSpPr>
+          <p:cNvPr id="5" name="TextBox 4"/>
+          <p:cNvSpPr txBox="1"/>
+          <p:nvPr/>
+        </p:nvSpPr>
+        <p:spPr>
+          <a:xfrm>
+            <a:off x="822960" y="2286000"/>
             <a:ext cx="10515600" cy="1097280"/>
           </a:xfrm>
           <a:prstGeom prst="rect">
@@ -5714,27 +6679,27 @@
               <a:spcAft>
                 <a:spcPts val="600"/>
               </a:spcAft>
-              <a:defRPr sz="2200">
-                <a:solidFill>
-                  <a:srgbClr val="F4F1EA"/>
+              <a:defRPr sz="2400">
+                <a:solidFill>
+                  <a:srgbClr val="9B968C"/>
                 </a:solidFill>
               </a:defRPr>
             </a:pPr>
             <a:r>
-              <a:t>• Moliyaviy yordam / grant — pilot va server xarajatlari</a:t>
-            </a:r>
-          </a:p>
-        </p:txBody>
-      </p:sp>
-      <p:sp>
-        <p:nvSpPr>
-          <p:cNvPr id="5" name="TextBox 4"/>
+              <a:t>Yo‘lGuard AI — спокойствие на дороге.</a:t>
+            </a:r>
+          </a:p>
+        </p:txBody>
+      </p:sp>
+      <p:sp>
+        <p:nvSpPr>
+          <p:cNvPr id="6" name="TextBox 5"/>
           <p:cNvSpPr txBox="1"/>
           <p:nvPr/>
         </p:nvSpPr>
         <p:spPr>
           <a:xfrm>
-            <a:off x="822960" y="2788920"/>
+            <a:off x="822960" y="2971800"/>
             <a:ext cx="10515600" cy="1097280"/>
           </a:xfrm>
           <a:prstGeom prst="rect">
@@ -5752,52 +6717,14 @@
               <a:spcAft>
                 <a:spcPts val="600"/>
               </a:spcAft>
-              <a:defRPr sz="2200">
-                <a:solidFill>
-                  <a:srgbClr val="F4F1EA"/>
+              <a:defRPr sz="2400">
+                <a:solidFill>
+                  <a:srgbClr val="9B968C"/>
                 </a:solidFill>
               </a:defRPr>
             </a:pPr>
             <a:r>
-              <a:t>• Mentorlik — sug‘urta va huquqiy soha bo‘yicha</a:t>
-            </a:r>
-          </a:p>
-        </p:txBody>
-      </p:sp>
-      <p:sp>
-        <p:nvSpPr>
-          <p:cNvPr id="6" name="TextBox 5"/>
-          <p:cNvSpPr txBox="1"/>
-          <p:nvPr/>
-        </p:nvSpPr>
-        <p:spPr>
-          <a:xfrm>
-            <a:off x="822960" y="3474720"/>
-            <a:ext cx="10515600" cy="1097280"/>
-          </a:xfrm>
-          <a:prstGeom prst="rect">
-            <a:avLst/>
-          </a:prstGeom>
-          <a:noFill/>
-        </p:spPr>
-        <p:txBody>
-          <a:bodyPr wrap="square">
-            <a:spAutoFit/>
-          </a:bodyPr>
-          <a:lstStyle/>
-          <a:p>
-            <a:pPr>
-              <a:spcAft>
-                <a:spcPts val="600"/>
-              </a:spcAft>
-              <a:defRPr sz="2200">
-                <a:solidFill>
-                  <a:srgbClr val="F4F1EA"/>
-                </a:solidFill>
-              </a:defRPr>
-            </a:pPr>
-            <a:r>
-              <a:t>• Investorlar bilan bog‘lanish — masshtablash uchun</a:t>
+              <a:t>Контакты: [телефон / Telegram]  •  Демо и код: github.com/shokhruh123/yolguard</a:t>
             </a:r>
           </a:p>
         </p:txBody>
@@ -5810,7 +6737,7 @@
         </p:nvSpPr>
         <p:spPr>
           <a:xfrm>
-            <a:off x="640080" y="6263640"/>
+            <a:off x="640080" y="6309360"/>
             <a:ext cx="10881360" cy="365760"/>
           </a:xfrm>
           <a:prstGeom prst="rect">
@@ -5832,7 +6759,7 @@
               </a:defRPr>
             </a:pPr>
             <a:r>
-              <a:t>Yo‘lGuard AI  •  MVP tayyor</a:t>
+              <a:t>Критерий: вопросы — понимание идеи — 10 б.</a:t>
             </a:r>
           </a:p>
         </p:txBody>
@@ -6163,4 +7090,324 @@
   </a:objectDefaults>
   <a:extraClrSchemeLst/>
 </a:theme>
+</file>
+
+<file path=ppt/theme/theme2.xml><?xml version="1.0" encoding="utf-8"?>
+<a:theme xmlns:a="http://schemas.openxmlformats.org/drawingml/2006/main" name="Office Theme">
+  <a:themeElements>
+    <a:clrScheme name="Office">
+      <a:dk1>
+        <a:sysClr val="windowText" lastClr="000000"/>
+      </a:dk1>
+      <a:lt1>
+        <a:sysClr val="window" lastClr="FFFFFF"/>
+      </a:lt1>
+      <a:dk2>
+        <a:srgbClr val="1F497D"/>
+      </a:dk2>
+      <a:lt2>
+        <a:srgbClr val="EEECE1"/>
+      </a:lt2>
+      <a:accent1>
+        <a:srgbClr val="4F81BD"/>
+      </a:accent1>
+      <a:accent2>
+        <a:srgbClr val="C0504D"/>
+      </a:accent2>
+      <a:accent3>
+        <a:srgbClr val="9BBB59"/>
+      </a:accent3>
+      <a:accent4>
+        <a:srgbClr val="8064A2"/>
+      </a:accent4>
+      <a:accent5>
+        <a:srgbClr val="4BACC6"/>
+      </a:accent5>
+      <a:accent6>
+        <a:srgbClr val="F79646"/>
+      </a:accent6>
+      <a:hlink>
+        <a:srgbClr val="0000FF"/>
+      </a:hlink>
+      <a:folHlink>
+        <a:srgbClr val="800080"/>
+      </a:folHlink>
+    </a:clrScheme>
+    <a:fontScheme name="Office">
+      <a:majorFont>
+        <a:latin typeface="Calibri"/>
+        <a:ea typeface=""/>
+        <a:cs typeface=""/>
+        <a:font script="Jpan" typeface="ＭＳ Ｐゴシック"/>
+        <a:font script="Hang" typeface="맑은 고딕"/>
+        <a:font script="Hans" typeface="宋体"/>
+        <a:font script="Hant" typeface="新細明體"/>
+        <a:font script="Arab" typeface="Times New Roman"/>
+        <a:font script="Hebr" typeface="Times New Roman"/>
+        <a:font script="Thai" typeface="Angsana New"/>
+        <a:font script="Ethi" typeface="Nyala"/>
+        <a:font script="Beng" typeface="Vrinda"/>
+        <a:font script="Gujr" typeface="Shruti"/>
+        <a:font script="Khmr" typeface="MoolBoran"/>
+        <a:font script="Knda" typeface="Tunga"/>
+        <a:font script="Guru" typeface="Raavi"/>
+        <a:font script="Cans" typeface="Euphemia"/>
+        <a:font script="Cher" typeface="Plantagenet Cherokee"/>
+        <a:font script="Yiii" typeface="Microsoft Yi Baiti"/>
+        <a:font script="Tibt" typeface="Microsoft Himalaya"/>
+        <a:font script="Thaa" typeface="MV Boli"/>
+        <a:font script="Deva" typeface="Mangal"/>
+        <a:font script="Telu" typeface="Gautami"/>
+        <a:font script="Taml" typeface="Latha"/>
+        <a:font script="Syrc" typeface="Estrangelo Edessa"/>
+        <a:font script="Orya" typeface="Kalinga"/>
+        <a:font script="Mlym" typeface="Kartika"/>
+        <a:font script="Laoo" typeface="DokChampa"/>
+        <a:font script="Sinh" typeface="Iskoola Pota"/>
+        <a:font script="Mong" typeface="Mongolian Baiti"/>
+        <a:font script="Viet" typeface="Times New Roman"/>
+        <a:font script="Uigh" typeface="Microsoft Uighur"/>
+        <a:font script="Geor" typeface="Sylfaen"/>
+      </a:majorFont>
+      <a:minorFont>
+        <a:latin typeface="Calibri"/>
+        <a:ea typeface=""/>
+        <a:cs typeface=""/>
+        <a:font script="Jpan" typeface="ＭＳ Ｐゴシック"/>
+        <a:font script="Hang" typeface="맑은 고딕"/>
+        <a:font script="Hans" typeface="宋体"/>
+        <a:font script="Hant" typeface="新細明體"/>
+        <a:font script="Arab" typeface="Arial"/>
+        <a:font script="Hebr" typeface="Arial"/>
+        <a:font script="Thai" typeface="Cordia New"/>
+        <a:font script="Ethi" typeface="Nyala"/>
+        <a:font script="Beng" typeface="Vrinda"/>
+        <a:font script="Gujr" typeface="Shruti"/>
+        <a:font script="Khmr" typeface="DaunPenh"/>
+        <a:font script="Knda" typeface="Tunga"/>
+        <a:font script="Guru" typeface="Raavi"/>
+        <a:font script="Cans" typeface="Euphemia"/>
+        <a:font script="Cher" typeface="Plantagenet Cherokee"/>
+        <a:font script="Yiii" typeface="Microsoft Yi Baiti"/>
+        <a:font script="Tibt" typeface="Microsoft Himalaya"/>
+        <a:font script="Thaa" typeface="MV Boli"/>
+        <a:font script="Deva" typeface="Mangal"/>
+        <a:font script="Telu" typeface="Gautami"/>
+        <a:font script="Taml" typeface="Latha"/>
+        <a:font script="Syrc" typeface="Estrangelo Edessa"/>
+        <a:font script="Orya" typeface="Kalinga"/>
+        <a:font script="Mlym" typeface="Kartika"/>
+        <a:font script="Laoo" typeface="DokChampa"/>
+        <a:font script="Sinh" typeface="Iskoola Pota"/>
+        <a:font script="Mong" typeface="Mongolian Baiti"/>
+        <a:font script="Viet" typeface="Arial"/>
+        <a:font script="Uigh" typeface="Microsoft Uighur"/>
+        <a:font script="Geor" typeface="Sylfaen"/>
+      </a:minorFont>
+    </a:fontScheme>
+    <a:fmtScheme name="Office">
+      <a:fillStyleLst>
+        <a:solidFill>
+          <a:schemeClr val="phClr"/>
+        </a:solidFill>
+        <a:gradFill rotWithShape="1">
+          <a:gsLst>
+            <a:gs pos="0">
+              <a:schemeClr val="phClr">
+                <a:tint val="50000"/>
+                <a:satMod val="300000"/>
+              </a:schemeClr>
+            </a:gs>
+            <a:gs pos="35000">
+              <a:schemeClr val="phClr">
+                <a:tint val="37000"/>
+                <a:satMod val="300000"/>
+              </a:schemeClr>
+            </a:gs>
+            <a:gs pos="100000">
+              <a:schemeClr val="phClr">
+                <a:tint val="15000"/>
+                <a:satMod val="350000"/>
+              </a:schemeClr>
+            </a:gs>
+          </a:gsLst>
+          <a:lin ang="16200000" scaled="1"/>
+        </a:gradFill>
+        <a:gradFill rotWithShape="1">
+          <a:gsLst>
+            <a:gs pos="0">
+              <a:schemeClr val="phClr">
+                <a:tint val="100000"/>
+                <a:shade val="100000"/>
+                <a:satMod val="130000"/>
+              </a:schemeClr>
+            </a:gs>
+            <a:gs pos="100000">
+              <a:schemeClr val="phClr">
+                <a:tint val="50000"/>
+                <a:shade val="100000"/>
+                <a:satMod val="350000"/>
+              </a:schemeClr>
+            </a:gs>
+          </a:gsLst>
+          <a:lin ang="16200000" scaled="0"/>
+        </a:gradFill>
+      </a:fillStyleLst>
+      <a:lnStyleLst>
+        <a:ln w="9525" cap="flat" cmpd="sng" algn="ctr">
+          <a:solidFill>
+            <a:schemeClr val="phClr">
+              <a:shade val="95000"/>
+              <a:satMod val="105000"/>
+            </a:schemeClr>
+          </a:solidFill>
+          <a:prstDash val="solid"/>
+        </a:ln>
+        <a:ln w="25400" cap="flat" cmpd="sng" algn="ctr">
+          <a:solidFill>
+            <a:schemeClr val="phClr"/>
+          </a:solidFill>
+          <a:prstDash val="solid"/>
+        </a:ln>
+        <a:ln w="38100" cap="flat" cmpd="sng" algn="ctr">
+          <a:solidFill>
+            <a:schemeClr val="phClr"/>
+          </a:solidFill>
+          <a:prstDash val="solid"/>
+        </a:ln>
+      </a:lnStyleLst>
+      <a:effectStyleLst>
+        <a:effectStyle>
+          <a:effectLst>
+            <a:outerShdw blurRad="40000" dist="20000" dir="5400000" rotWithShape="0">
+              <a:srgbClr val="000000">
+                <a:alpha val="38000"/>
+              </a:srgbClr>
+            </a:outerShdw>
+          </a:effectLst>
+        </a:effectStyle>
+        <a:effectStyle>
+          <a:effectLst>
+            <a:outerShdw blurRad="40000" dist="23000" dir="5400000" rotWithShape="0">
+              <a:srgbClr val="000000">
+                <a:alpha val="35000"/>
+              </a:srgbClr>
+            </a:outerShdw>
+          </a:effectLst>
+        </a:effectStyle>
+        <a:effectStyle>
+          <a:effectLst>
+            <a:outerShdw blurRad="40000" dist="23000" dir="5400000" rotWithShape="0">
+              <a:srgbClr val="000000">
+                <a:alpha val="35000"/>
+              </a:srgbClr>
+            </a:outerShdw>
+          </a:effectLst>
+          <a:scene3d>
+            <a:camera prst="orthographicFront">
+              <a:rot lat="0" lon="0" rev="0"/>
+            </a:camera>
+            <a:lightRig rig="threePt" dir="t">
+              <a:rot lat="0" lon="0" rev="1200000"/>
+            </a:lightRig>
+          </a:scene3d>
+          <a:sp3d>
+            <a:bevelT w="63500" h="25400"/>
+          </a:sp3d>
+        </a:effectStyle>
+      </a:effectStyleLst>
+      <a:bgFillStyleLst>
+        <a:solidFill>
+          <a:schemeClr val="phClr"/>
+        </a:solidFill>
+        <a:gradFill rotWithShape="1">
+          <a:gsLst>
+            <a:gs pos="0">
+              <a:schemeClr val="phClr">
+                <a:tint val="40000"/>
+                <a:satMod val="350000"/>
+              </a:schemeClr>
+            </a:gs>
+            <a:gs pos="40000">
+              <a:schemeClr val="phClr">
+                <a:tint val="45000"/>
+                <a:shade val="99000"/>
+                <a:satMod val="350000"/>
+              </a:schemeClr>
+            </a:gs>
+            <a:gs pos="100000">
+              <a:schemeClr val="phClr">
+                <a:shade val="20000"/>
+                <a:satMod val="255000"/>
+              </a:schemeClr>
+            </a:gs>
+          </a:gsLst>
+          <a:path path="circle">
+            <a:fillToRect l="50000" t="-80000" r="50000" b="180000"/>
+          </a:path>
+        </a:gradFill>
+        <a:gradFill rotWithShape="1">
+          <a:gsLst>
+            <a:gs pos="0">
+              <a:schemeClr val="phClr">
+                <a:tint val="80000"/>
+                <a:satMod val="300000"/>
+              </a:schemeClr>
+            </a:gs>
+            <a:gs pos="100000">
+              <a:schemeClr val="phClr">
+                <a:shade val="30000"/>
+                <a:satMod val="200000"/>
+              </a:schemeClr>
+            </a:gs>
+          </a:gsLst>
+          <a:path path="circle">
+            <a:fillToRect l="50000" t="50000" r="50000" b="50000"/>
+          </a:path>
+        </a:gradFill>
+      </a:bgFillStyleLst>
+    </a:fmtScheme>
+  </a:themeElements>
+  <a:objectDefaults>
+    <a:spDef>
+      <a:spPr/>
+      <a:bodyPr/>
+      <a:lstStyle/>
+      <a:style>
+        <a:lnRef idx="1">
+          <a:schemeClr val="accent1"/>
+        </a:lnRef>
+        <a:fillRef idx="3">
+          <a:schemeClr val="accent1"/>
+        </a:fillRef>
+        <a:effectRef idx="2">
+          <a:schemeClr val="accent1"/>
+        </a:effectRef>
+        <a:fontRef idx="minor">
+          <a:schemeClr val="lt1"/>
+        </a:fontRef>
+      </a:style>
+    </a:spDef>
+    <a:lnDef>
+      <a:spPr/>
+      <a:bodyPr/>
+      <a:lstStyle/>
+      <a:style>
+        <a:lnRef idx="2">
+          <a:schemeClr val="accent1"/>
+        </a:lnRef>
+        <a:fillRef idx="0">
+          <a:schemeClr val="accent1"/>
+        </a:fillRef>
+        <a:effectRef idx="1">
+          <a:schemeClr val="accent1"/>
+        </a:effectRef>
+        <a:fontRef idx="minor">
+          <a:schemeClr val="tx1"/>
+        </a:fontRef>
+      </a:style>
+    </a:lnDef>
+  </a:objectDefaults>
+  <a:extraClrSchemeLst/>
+</a:theme>
 </file>
</xml_diff>

<commit_message>
Pitch: analogues differentiation (no direct analogue in UZ)
</commit_message>
<xml_diff>
--- a/YoLGuard_Startup_Presentation.pptx
+++ b/YoLGuard_Startup_Presentation.pptx
@@ -5489,7 +5489,7 @@
               <a:spcAft>
                 <a:spcPts val="600"/>
               </a:spcAft>
-              <a:defRPr sz="2000">
+              <a:defRPr sz="1900">
                 <a:solidFill>
                   <a:srgbClr val="F4F1EA"/>
                 </a:solidFill>
@@ -5527,7 +5527,7 @@
               <a:spcAft>
                 <a:spcPts val="600"/>
               </a:spcAft>
-              <a:defRPr sz="2000">
+              <a:defRPr sz="1900">
                 <a:solidFill>
                   <a:srgbClr val="F4F1EA"/>
                 </a:solidFill>
@@ -5565,7 +5565,7 @@
               <a:spcAft>
                 <a:spcPts val="600"/>
               </a:spcAft>
-              <a:defRPr sz="2000">
+              <a:defRPr sz="1900">
                 <a:solidFill>
                   <a:srgbClr val="F4F1EA"/>
                 </a:solidFill>
@@ -5603,13 +5603,51 @@
               <a:spcAft>
                 <a:spcPts val="600"/>
               </a:spcAft>
-              <a:defRPr sz="2000">
+              <a:defRPr sz="1900">
                 <a:solidFill>
                   <a:srgbClr val="F4F1EA"/>
                 </a:solidFill>
               </a:defRPr>
             </a:pPr>
             <a:r>
+              <a:t>• Отличие от аналогов: Госуслуги Авто (РФ) и Европротокол (KZ) — без ИИ; Tractable/Ravin — B2B-инструменты страховых без флоу водитель→сотрудник; в Узбекистане прямого аналога нет</a:t>
+            </a:r>
+          </a:p>
+        </p:txBody>
+      </p:sp>
+      <p:sp>
+        <p:nvSpPr>
+          <p:cNvPr id="9" name="TextBox 8"/>
+          <p:cNvSpPr txBox="1"/>
+          <p:nvPr/>
+        </p:nvSpPr>
+        <p:spPr>
+          <a:xfrm>
+            <a:off x="822960" y="5486400"/>
+            <a:ext cx="10515600" cy="1097280"/>
+          </a:xfrm>
+          <a:prstGeom prst="rect">
+            <a:avLst/>
+          </a:prstGeom>
+          <a:noFill/>
+        </p:spPr>
+        <p:txBody>
+          <a:bodyPr wrap="square">
+            <a:spAutoFit/>
+          </a:bodyPr>
+          <a:lstStyle/>
+          <a:p>
+            <a:pPr>
+              <a:spcAft>
+                <a:spcPts val="600"/>
+              </a:spcAft>
+              <a:defRPr sz="1900">
+                <a:solidFill>
+                  <a:srgbClr val="F4F1EA"/>
+                </a:solidFill>
+              </a:defRPr>
+            </a:pPr>
+            <a:r>
               <a:t>• ЖИВОЕ ДЕМО: SOS → фото → разбор ИИ → вердикт (MVP: Android, API, EXE, 45 тестов)</a:t>
             </a:r>
           </a:p>
@@ -5617,7 +5655,7 @@
       </p:sp>
       <p:sp>
         <p:nvSpPr>
-          <p:cNvPr id="9" name="TextBox 8"/>
+          <p:cNvPr id="10" name="TextBox 9"/>
           <p:cNvSpPr txBox="1"/>
           <p:nvPr/>
         </p:nvSpPr>

</xml_diff>

<commit_message>
Pitch: 5-minute fixation effect bullet
</commit_message>
<xml_diff>
--- a/YoLGuard_Startup_Presentation.pptx
+++ b/YoLGuard_Startup_Presentation.pptx
@@ -6179,14 +6179,14 @@
               <a:spcAft>
                 <a:spcPts val="600"/>
               </a:spcAft>
-              <a:defRPr sz="2200">
+              <a:defRPr sz="2100">
                 <a:solidFill>
                   <a:srgbClr val="F4F1EA"/>
                 </a:solidFill>
               </a:defRPr>
             </a:pPr>
             <a:r>
-              <a:t>• Метрика: время до освобождения полосы (считаем cleared_lane_at уже сейчас)</a:t>
+              <a:t>• Фиксация водителем — около 5 минут (триаж 30 сек + фото + ИИ), дальше полоса свободна</a:t>
             </a:r>
           </a:p>
         </p:txBody>
@@ -6217,14 +6217,14 @@
               <a:spcAft>
                 <a:spcPts val="600"/>
               </a:spcAft>
-              <a:defRPr sz="2200">
+              <a:defRPr sz="2100">
                 <a:solidFill>
                   <a:srgbClr val="F4F1EA"/>
                 </a:solidFill>
               </a:defRPr>
             </a:pPr>
             <a:r>
-              <a:t>• Пилот: ГАИ/страховая одного района → вся страна (B2G-масштабирование)</a:t>
+              <a:t>• Метрика уже считается: время до освобождения полосы (cleared_lane_at в базе)</a:t>
             </a:r>
           </a:p>
         </p:txBody>
@@ -6255,13 +6255,51 @@
               <a:spcAft>
                 <a:spcPts val="600"/>
               </a:spcAft>
-              <a:defRPr sz="2200">
+              <a:defRPr sz="2100">
                 <a:solidFill>
                   <a:srgbClr val="F4F1EA"/>
                 </a:solidFill>
               </a:defRPr>
             </a:pPr>
             <a:r>
+              <a:t>• Пилот: ГАИ/страховая одного района → вся страна (B2G-масштабирование)</a:t>
+            </a:r>
+          </a:p>
+        </p:txBody>
+      </p:sp>
+      <p:sp>
+        <p:nvSpPr>
+          <p:cNvPr id="8" name="TextBox 7"/>
+          <p:cNvSpPr txBox="1"/>
+          <p:nvPr/>
+        </p:nvSpPr>
+        <p:spPr>
+          <a:xfrm>
+            <a:off x="822960" y="4251960"/>
+            <a:ext cx="10515600" cy="1097280"/>
+          </a:xfrm>
+          <a:prstGeom prst="rect">
+            <a:avLst/>
+          </a:prstGeom>
+          <a:noFill/>
+        </p:spPr>
+        <p:txBody>
+          <a:bodyPr wrap="square">
+            <a:spAutoFit/>
+          </a:bodyPr>
+          <a:lstStyle/>
+          <a:p>
+            <a:pPr>
+              <a:spcAft>
+                <a:spcPts val="600"/>
+              </a:spcAft>
+              <a:defRPr sz="2100">
+                <a:solidFill>
+                  <a:srgbClr val="F4F1EA"/>
+                </a:solidFill>
+              </a:defRPr>
+            </a:pPr>
+            <a:r>
               <a:t>• Пользователи: водители, сотрудники ДПС, страховщики</a:t>
             </a:r>
           </a:p>
@@ -6269,7 +6307,7 @@
       </p:sp>
       <p:sp>
         <p:nvSpPr>
-          <p:cNvPr id="8" name="TextBox 7"/>
+          <p:cNvPr id="9" name="TextBox 8"/>
           <p:cNvSpPr txBox="1"/>
           <p:nvPr/>
         </p:nvSpPr>

</xml_diff>

<commit_message>
Pitch: Huawei next step (Map Kit key)
</commit_message>
<xml_diff>
--- a/YoLGuard_Startup_Presentation.pptx
+++ b/YoLGuard_Startup_Presentation.pptx
@@ -5853,7 +5853,7 @@
               <a:spcAft>
                 <a:spcPts val="600"/>
               </a:spcAft>
-              <a:defRPr sz="2000">
+              <a:defRPr sz="1900">
                 <a:solidFill>
                   <a:srgbClr val="F4F1EA"/>
                 </a:solidFill>
@@ -5891,14 +5891,14 @@
               <a:spcAft>
                 <a:spcPts val="600"/>
               </a:spcAft>
-              <a:defRPr sz="2000">
+              <a:defRPr sz="1900">
                 <a:solidFill>
                   <a:srgbClr val="F4F1EA"/>
                 </a:solidFill>
               </a:defRPr>
             </a:pPr>
             <a:r>
-              <a:t>• ПЛАН: HMS Push Kit — пуши о вердикте вместо polling; Map Kit — карта ДТП и GPS-координаты уже собираем</a:t>
+              <a:t>• ПЛАН: HMS Push Kit — пуши о вердикте вместо polling; Map Kit — карта ДТП (GPS-координаты уже собираем)</a:t>
             </a:r>
           </a:p>
         </p:txBody>
@@ -5929,7 +5929,7 @@
               <a:spcAft>
                 <a:spcPts val="600"/>
               </a:spcAft>
-              <a:defRPr sz="2000">
+              <a:defRPr sz="1900">
                 <a:solidFill>
                   <a:srgbClr val="F4F1EA"/>
                 </a:solidFill>
@@ -5967,13 +5967,51 @@
               <a:spcAft>
                 <a:spcPts val="600"/>
               </a:spcAft>
-              <a:defRPr sz="2000">
+              <a:defRPr sz="1900">
                 <a:solidFill>
                   <a:srgbClr val="F4F1EA"/>
                 </a:solidFill>
               </a:defRPr>
             </a:pPr>
             <a:r>
+              <a:t>• Ближайший шаг: ключ Map Kit из консоли AppGallery Connect → карта места ДТП в досье</a:t>
+            </a:r>
+          </a:p>
+        </p:txBody>
+      </p:sp>
+      <p:sp>
+        <p:nvSpPr>
+          <p:cNvPr id="9" name="TextBox 8"/>
+          <p:cNvSpPr txBox="1"/>
+          <p:nvPr/>
+        </p:nvSpPr>
+        <p:spPr>
+          <a:xfrm>
+            <a:off x="822960" y="5166360"/>
+            <a:ext cx="10515600" cy="1097280"/>
+          </a:xfrm>
+          <a:prstGeom prst="rect">
+            <a:avLst/>
+          </a:prstGeom>
+          <a:noFill/>
+        </p:spPr>
+        <p:txBody>
+          <a:bodyPr wrap="square">
+            <a:spAutoFit/>
+          </a:bodyPr>
+          <a:lstStyle/>
+          <a:p>
+            <a:pPr>
+              <a:spcAft>
+                <a:spcPts val="600"/>
+              </a:spcAft>
+              <a:defRPr sz="1900">
+                <a:solidFill>
+                  <a:srgbClr val="F4F1EA"/>
+                </a:solidFill>
+              </a:defRPr>
+            </a:pPr>
+            <a:r>
               <a:t>• Реализуемо за недели: push-интерфейс уже абстрагирован (сервис push.py + SW)</a:t>
             </a:r>
           </a:p>
@@ -5981,7 +6019,7 @@
       </p:sp>
       <p:sp>
         <p:nvSpPr>
-          <p:cNvPr id="9" name="TextBox 8"/>
+          <p:cNvPr id="10" name="TextBox 9"/>
           <p:cNvSpPr txBox="1"/>
           <p:nvPr/>
         </p:nvSpPr>

</xml_diff>